<commit_message>
Prepare Greenlit hackathon release
</commit_message>
<xml_diff>
--- a/docs/hackathon/greenlit-blueprint-hackathon-deck.pptx
+++ b/docs/hackathon/greenlit-blueprint-hackathon-deck.pptx
@@ -2,20 +2,20 @@
 <file path=ppt/presentation.xml><?xml version="1.0" encoding="utf-8"?>
 <p:presentation xmlns:p="http://schemas.openxmlformats.org/presentationml/2006/main">
   <p:sldMasterIdLst>
-    <p:sldMasterId xmlns:r="http://schemas.openxmlformats.org/officeDocument/2006/relationships" id="2147483648" r:id="R1b4e6414aed74536"/>
+    <p:sldMasterId xmlns:r="http://schemas.openxmlformats.org/officeDocument/2006/relationships" id="2147483648" r:id="R114a8052dc9748c8"/>
   </p:sldMasterIdLst>
   <p:notesMasterIdLst>
-    <p:notesMasterId xmlns:r="http://schemas.openxmlformats.org/officeDocument/2006/relationships" r:id="Recd8efbef43d4a61"/>
+    <p:notesMasterId xmlns:r="http://schemas.openxmlformats.org/officeDocument/2006/relationships" r:id="R45e8478702be4dcb"/>
   </p:notesMasterIdLst>
   <p:sldIdLst>
-    <p:sldId xmlns:r="http://schemas.openxmlformats.org/officeDocument/2006/relationships" id="256" r:id="Rf6acda5706ae4f8d"/>
-    <p:sldId xmlns:r="http://schemas.openxmlformats.org/officeDocument/2006/relationships" id="257" r:id="Re72e437cbc2b421f"/>
-    <p:sldId xmlns:r="http://schemas.openxmlformats.org/officeDocument/2006/relationships" id="258" r:id="R5c1a7f384a7b4201"/>
-    <p:sldId xmlns:r="http://schemas.openxmlformats.org/officeDocument/2006/relationships" id="259" r:id="Rec16cdf468dd44dd"/>
-    <p:sldId xmlns:r="http://schemas.openxmlformats.org/officeDocument/2006/relationships" id="260" r:id="R826abbdb3c5c4489"/>
-    <p:sldId xmlns:r="http://schemas.openxmlformats.org/officeDocument/2006/relationships" id="261" r:id="R116946665f094056"/>
-    <p:sldId xmlns:r="http://schemas.openxmlformats.org/officeDocument/2006/relationships" id="262" r:id="R20c2228f90904a96"/>
-    <p:sldId xmlns:r="http://schemas.openxmlformats.org/officeDocument/2006/relationships" id="263" r:id="R2947ca2e1a324a43"/>
+    <p:sldId xmlns:r="http://schemas.openxmlformats.org/officeDocument/2006/relationships" id="256" r:id="R6ab7e76ad9a8475d"/>
+    <p:sldId xmlns:r="http://schemas.openxmlformats.org/officeDocument/2006/relationships" id="257" r:id="R9a689c749dd4431a"/>
+    <p:sldId xmlns:r="http://schemas.openxmlformats.org/officeDocument/2006/relationships" id="258" r:id="Ra98c56e45f904ef2"/>
+    <p:sldId xmlns:r="http://schemas.openxmlformats.org/officeDocument/2006/relationships" id="259" r:id="R6767acc8d31d431c"/>
+    <p:sldId xmlns:r="http://schemas.openxmlformats.org/officeDocument/2006/relationships" id="260" r:id="R92fb4fa8d68d4cde"/>
+    <p:sldId xmlns:r="http://schemas.openxmlformats.org/officeDocument/2006/relationships" id="261" r:id="R77a7f846cbf7444d"/>
+    <p:sldId xmlns:r="http://schemas.openxmlformats.org/officeDocument/2006/relationships" id="262" r:id="Rc59a4e4fc6164a84"/>
+    <p:sldId xmlns:r="http://schemas.openxmlformats.org/officeDocument/2006/relationships" id="263" r:id="Rd0161be2d308483e"/>
   </p:sldIdLst>
   <p:sldSz cx="12192000" cy="6858000"/>
   <p:notesSz cx="6858000" cy="9144000"/>
@@ -1062,7 +1062,7 @@
   </p:cSld>
   <p:clrMap bg1="lt1" tx1="dk1" bg2="lt2" tx2="dk2" accent1="accent1" accent2="accent2" accent3="accent3" accent4="accent4" accent5="accent5" accent6="accent6" hlink="hlink" folHlink="folHlink"/>
   <p:sldLayoutIdLst>
-    <p:sldLayoutId xmlns:r="http://schemas.openxmlformats.org/officeDocument/2006/relationships" id="2147483649" r:id="R6e6fe351be5946fe"/>
+    <p:sldLayoutId xmlns:r="http://schemas.openxmlformats.org/officeDocument/2006/relationships" id="2147483649" r:id="Ra71ce77e501546c0"/>
   </p:sldLayoutIdLst>
   <p:txStyles>
     <p:titleStyle>
@@ -1650,7 +1650,7 @@
           <p:nvPr/>
         </p:nvPicPr>
         <p:blipFill>
-          <a:blip xmlns:r="http://schemas.openxmlformats.org/officeDocument/2006/relationships" xmlns:a="http://schemas.openxmlformats.org/drawingml/2006/main" r:embed="R25db78e73067430d"/>
+          <a:blip xmlns:r="http://schemas.openxmlformats.org/officeDocument/2006/relationships" xmlns:a="http://schemas.openxmlformats.org/drawingml/2006/main" r:embed="R3384be18fa96476e"/>
           <a:stretch xmlns:a="http://schemas.openxmlformats.org/drawingml/2006/main"/>
         </p:blipFill>
         <p:spPr>
@@ -1982,7 +1982,7 @@
                   <a:srgbClr val="12241C"/>
                 </a:solidFill>
               </a:rPr>
-              <a:t>Built and tested July 19–28, 2026</a:t>
+              <a:t>Built during Blueprint 2026</a:t>
             </a:r>
           </a:p>
         </p:txBody>
@@ -4504,21 +4504,19 @@
           <p:nvPr/>
         </p:nvPicPr>
         <p:blipFill>
-          <a:blip xmlns:r="http://schemas.openxmlformats.org/officeDocument/2006/relationships" xmlns:a="http://schemas.openxmlformats.org/drawingml/2006/main" r:embed="R9fb01cf4251e468e"/>
+          <a:blip xmlns:r="http://schemas.openxmlformats.org/officeDocument/2006/relationships" xmlns:a="http://schemas.openxmlformats.org/drawingml/2006/main" r:embed="R436072ed5be94d1d"/>
           <a:srcRect xmlns:a="http://schemas.openxmlformats.org/drawingml/2006/main" l="0" t="1064" r="0" b="1064"/>
           <a:stretch xmlns:a="http://schemas.openxmlformats.org/drawingml/2006/main">
             <a:fillRect l="0" t="0" r="0" b="0"/>
           </a:stretch>
         </p:blipFill>
         <p:spPr>
-          <a:xfrm xmlns:a="http://schemas.openxmlformats.org/drawingml/2006/main">
+          <a:xfrm xmlns:a="http://schemas.openxmlformats.org/drawingml/2006/main" flipH="0" flipV="0">
             <a:off x="5191125" y="2238375"/>
             <a:ext cx="6315075" cy="3476625"/>
           </a:xfrm>
           <a:prstGeom xmlns:a="http://schemas.openxmlformats.org/drawingml/2006/main" prst="roundRect">
-            <a:avLst>
-              <a:gd name="adj" fmla="val 2192"/>
-            </a:avLst>
+            <a:avLst/>
           </a:prstGeom>
         </p:spPr>
       </p:pic>
@@ -4764,21 +4762,19 @@
           <p:nvPr/>
         </p:nvPicPr>
         <p:blipFill>
-          <a:blip xmlns:r="http://schemas.openxmlformats.org/officeDocument/2006/relationships" xmlns:a="http://schemas.openxmlformats.org/drawingml/2006/main" r:embed="R8e7b970ac8b942aa"/>
+          <a:blip xmlns:r="http://schemas.openxmlformats.org/officeDocument/2006/relationships" xmlns:a="http://schemas.openxmlformats.org/drawingml/2006/main" r:embed="Rb7707edffef3457d"/>
           <a:srcRect xmlns:a="http://schemas.openxmlformats.org/drawingml/2006/main" l="112" t="0" r="112" b="0"/>
           <a:stretch xmlns:a="http://schemas.openxmlformats.org/drawingml/2006/main">
             <a:fillRect l="0" t="0" r="0" b="0"/>
           </a:stretch>
         </p:blipFill>
         <p:spPr>
-          <a:xfrm xmlns:a="http://schemas.openxmlformats.org/drawingml/2006/main">
+          <a:xfrm xmlns:a="http://schemas.openxmlformats.org/drawingml/2006/main" flipH="0" flipV="0">
             <a:off x="685800" y="2095500"/>
             <a:ext cx="7096125" cy="4000500"/>
           </a:xfrm>
           <a:prstGeom xmlns:a="http://schemas.openxmlformats.org/drawingml/2006/main" prst="roundRect">
-            <a:avLst>
-              <a:gd name="adj" fmla="val 1905"/>
-            </a:avLst>
+            <a:avLst/>
           </a:prstGeom>
         </p:spPr>
       </p:pic>
@@ -5163,7 +5159,7 @@
                   <a:srgbClr val="12241C"/>
                 </a:solidFill>
               </a:rPr>
-              <a:t>The decision becomes an invoice-ready record.</a:t>
+              <a:t>The walkthrough ends in an invoice-ready sample.</a:t>
             </a:r>
           </a:p>
         </p:txBody>
@@ -5214,7 +5210,7 @@
                   <a:srgbClr val="556159"/>
                 </a:solidFill>
               </a:rPr>
-              <a:t>One retained view connects the milestone value, frozen revision, observed build, named decision, and print-ready receipt.</a:t>
+              <a:t>One printable sample connects the milestone value, revision 1, observed build, local-only decision, and approval format.</a:t>
             </a:r>
           </a:p>
         </p:txBody>
@@ -5316,7 +5312,7 @@
                   <a:srgbClr val="12241C"/>
                 </a:solidFill>
               </a:rPr>
-              <a:t>A business approval record and billing handoff.</a:t>
+              <a:t>A printable sample of the approval and billing handoff.</a:t>
             </a:r>
           </a:p>
         </p:txBody>
@@ -5432,21 +5428,19 @@
           <p:nvPr/>
         </p:nvPicPr>
         <p:blipFill>
-          <a:blip xmlns:r="http://schemas.openxmlformats.org/officeDocument/2006/relationships" xmlns:a="http://schemas.openxmlformats.org/drawingml/2006/main" r:embed="Ref4c6178e0d74af8"/>
+          <a:blip xmlns:r="http://schemas.openxmlformats.org/officeDocument/2006/relationships" xmlns:a="http://schemas.openxmlformats.org/drawingml/2006/main" r:embed="R223091b29d90427d"/>
           <a:srcRect xmlns:a="http://schemas.openxmlformats.org/drawingml/2006/main" l="9428" t="0" r="9428" b="0"/>
           <a:stretch xmlns:a="http://schemas.openxmlformats.org/drawingml/2006/main">
             <a:fillRect l="0" t="0" r="0" b="0"/>
           </a:stretch>
         </p:blipFill>
         <p:spPr>
-          <a:xfrm xmlns:a="http://schemas.openxmlformats.org/drawingml/2006/main">
+          <a:xfrm xmlns:a="http://schemas.openxmlformats.org/drawingml/2006/main" flipH="0" flipV="0">
             <a:off x="5048250" y="1666875"/>
             <a:ext cx="6457950" cy="4476750"/>
           </a:xfrm>
           <a:prstGeom xmlns:a="http://schemas.openxmlformats.org/drawingml/2006/main" prst="roundRect">
-            <a:avLst>
-              <a:gd name="adj" fmla="val 1702"/>
-            </a:avLst>
+            <a:avLst/>
           </a:prstGeom>
         </p:spPr>
       </p:pic>
@@ -6271,7 +6265,7 @@
                   <a:srgbClr val="12241C"/>
                 </a:solidFill>
               </a:rPr>
-              <a:t>64 commits since July 19; a complete agency-to-client workflow.</a:t>
+              <a:t>Built during Blueprint 2026; a complete agency-to-client workflow.</a:t>
             </a:r>
           </a:p>
         </p:txBody>
@@ -6373,7 +6367,7 @@
                   <a:srgbClr val="12241C"/>
                 </a:solidFill>
               </a:rPr>
-              <a:t>245 automated tests and 128 end-to-end checks passed.</a:t>
+              <a:t>Typecheck, lint, tests, build, migrations, and browser flow passed.</a:t>
             </a:r>
           </a:p>
         </p:txBody>
@@ -6628,7 +6622,7 @@
                   <a:srgbClr val="12241C"/>
                 </a:solidFill>
               </a:rPr>
-              <a:t>anayagarwalla-ai/milestoneproof</a:t>
+              <a:t>anayagarwalla-ai/greenlit</a:t>
             </a:r>
           </a:p>
         </p:txBody>

</xml_diff>

<commit_message>
Polish hackathon presentation deck
</commit_message>
<xml_diff>
--- a/docs/hackathon/greenlit-blueprint-hackathon-deck.pptx
+++ b/docs/hackathon/greenlit-blueprint-hackathon-deck.pptx
@@ -2,20 +2,20 @@
 <file path=ppt/presentation.xml><?xml version="1.0" encoding="utf-8"?>
 <p:presentation xmlns:p="http://schemas.openxmlformats.org/presentationml/2006/main">
   <p:sldMasterIdLst>
-    <p:sldMasterId xmlns:r="http://schemas.openxmlformats.org/officeDocument/2006/relationships" id="2147483648" r:id="R114a8052dc9748c8"/>
+    <p:sldMasterId xmlns:r="http://schemas.openxmlformats.org/officeDocument/2006/relationships" id="2147483648" r:id="R2bf2593090c74d84"/>
   </p:sldMasterIdLst>
   <p:notesMasterIdLst>
-    <p:notesMasterId xmlns:r="http://schemas.openxmlformats.org/officeDocument/2006/relationships" r:id="R45e8478702be4dcb"/>
+    <p:notesMasterId xmlns:r="http://schemas.openxmlformats.org/officeDocument/2006/relationships" r:id="R43235e75b6134f88"/>
   </p:notesMasterIdLst>
   <p:sldIdLst>
-    <p:sldId xmlns:r="http://schemas.openxmlformats.org/officeDocument/2006/relationships" id="256" r:id="R6ab7e76ad9a8475d"/>
-    <p:sldId xmlns:r="http://schemas.openxmlformats.org/officeDocument/2006/relationships" id="257" r:id="R9a689c749dd4431a"/>
-    <p:sldId xmlns:r="http://schemas.openxmlformats.org/officeDocument/2006/relationships" id="258" r:id="Ra98c56e45f904ef2"/>
-    <p:sldId xmlns:r="http://schemas.openxmlformats.org/officeDocument/2006/relationships" id="259" r:id="R6767acc8d31d431c"/>
-    <p:sldId xmlns:r="http://schemas.openxmlformats.org/officeDocument/2006/relationships" id="260" r:id="R92fb4fa8d68d4cde"/>
-    <p:sldId xmlns:r="http://schemas.openxmlformats.org/officeDocument/2006/relationships" id="261" r:id="R77a7f846cbf7444d"/>
-    <p:sldId xmlns:r="http://schemas.openxmlformats.org/officeDocument/2006/relationships" id="262" r:id="Rc59a4e4fc6164a84"/>
-    <p:sldId xmlns:r="http://schemas.openxmlformats.org/officeDocument/2006/relationships" id="263" r:id="Rd0161be2d308483e"/>
+    <p:sldId xmlns:r="http://schemas.openxmlformats.org/officeDocument/2006/relationships" id="256" r:id="R30c26f076b2e4047"/>
+    <p:sldId xmlns:r="http://schemas.openxmlformats.org/officeDocument/2006/relationships" id="257" r:id="R47576086f7154e81"/>
+    <p:sldId xmlns:r="http://schemas.openxmlformats.org/officeDocument/2006/relationships" id="258" r:id="Rb4cfe1078a9c470a"/>
+    <p:sldId xmlns:r="http://schemas.openxmlformats.org/officeDocument/2006/relationships" id="259" r:id="R604f4c7a97d84015"/>
+    <p:sldId xmlns:r="http://schemas.openxmlformats.org/officeDocument/2006/relationships" id="260" r:id="Rc3cb7415069640b1"/>
+    <p:sldId xmlns:r="http://schemas.openxmlformats.org/officeDocument/2006/relationships" id="261" r:id="Rc0457f165f3c4d79"/>
+    <p:sldId xmlns:r="http://schemas.openxmlformats.org/officeDocument/2006/relationships" id="262" r:id="R085fcf5e960e4e20"/>
+    <p:sldId xmlns:r="http://schemas.openxmlformats.org/officeDocument/2006/relationships" id="263" r:id="R17b8492d0ff749b8"/>
   </p:sldIdLst>
   <p:sldSz cx="12192000" cy="6858000"/>
   <p:notesSz cx="6858000" cy="9144000"/>
@@ -1062,7 +1062,7 @@
   </p:cSld>
   <p:clrMap bg1="lt1" tx1="dk1" bg2="lt2" tx2="dk2" accent1="accent1" accent2="accent2" accent3="accent3" accent4="accent4" accent5="accent5" accent6="accent6" hlink="hlink" folHlink="folHlink"/>
   <p:sldLayoutIdLst>
-    <p:sldLayoutId xmlns:r="http://schemas.openxmlformats.org/officeDocument/2006/relationships" id="2147483649" r:id="Ra71ce77e501546c0"/>
+    <p:sldLayoutId xmlns:r="http://schemas.openxmlformats.org/officeDocument/2006/relationships" id="2147483649" r:id="R17b08866593f49f5"/>
   </p:sldLayoutIdLst>
   <p:txStyles>
     <p:titleStyle>
@@ -1631,11 +1631,11 @@
             <a:avLst/>
           </a:prstGeom>
           <a:solidFill xmlns:a="http://schemas.openxmlformats.org/drawingml/2006/main">
-            <a:srgbClr val="D6FF61"/>
+            <a:srgbClr val="DCE8DF"/>
           </a:solidFill>
           <a:ln xmlns:a="http://schemas.openxmlformats.org/drawingml/2006/main" w="0">
             <a:solidFill>
-              <a:srgbClr val="D6FF61"/>
+              <a:srgbClr val="DCE8DF"/>
             </a:solidFill>
             <a:prstDash val="solid"/>
           </a:ln>
@@ -1650,7 +1650,7 @@
           <p:nvPr/>
         </p:nvPicPr>
         <p:blipFill>
-          <a:blip xmlns:r="http://schemas.openxmlformats.org/officeDocument/2006/relationships" xmlns:a="http://schemas.openxmlformats.org/drawingml/2006/main" r:embed="R3384be18fa96476e"/>
+          <a:blip xmlns:r="http://schemas.openxmlformats.org/officeDocument/2006/relationships" xmlns:a="http://schemas.openxmlformats.org/drawingml/2006/main" r:embed="R7f192d708a46460c"/>
           <a:stretch xmlns:a="http://schemas.openxmlformats.org/drawingml/2006/main"/>
         </p:blipFill>
         <p:spPr>
@@ -1760,7 +1760,7 @@
                   <a:srgbClr val="EAE6DC"/>
                 </a:solidFill>
               </a:rPr>
-              <a:t>AI-assisted acceptance evidence for web agencies.</a:t>
+              <a:t>For web agencies that need a clear approval trail.</a:t>
             </a:r>
           </a:p>
         </p:txBody>
@@ -1781,8 +1781,8 @@
         </p:nvSpPr>
         <p:spPr>
           <a:xfrm xmlns:a="http://schemas.openxmlformats.org/drawingml/2006/main">
-            <a:off x="8763000" y="1238250"/>
-            <a:ext cx="2714625" cy="285750"/>
+            <a:off x="8858250" y="1238250"/>
+            <a:ext cx="2809875" cy="285750"/>
           </a:xfrm>
           <a:prstGeom xmlns:a="http://schemas.openxmlformats.org/drawingml/2006/main" prst="rect">
             <a:avLst/>
@@ -1832,8 +1832,8 @@
         </p:nvSpPr>
         <p:spPr>
           <a:xfrm xmlns:a="http://schemas.openxmlformats.org/drawingml/2006/main">
-            <a:off x="8763000" y="2190750"/>
-            <a:ext cx="2762250" cy="2000250"/>
+            <a:off x="8524875" y="2238375"/>
+            <a:ext cx="3476625" cy="1666875"/>
           </a:xfrm>
           <a:prstGeom xmlns:a="http://schemas.openxmlformats.org/drawingml/2006/main" prst="rect">
             <a:avLst/>
@@ -1862,7 +1862,7 @@
                   <a:srgbClr val="12241C"/>
                 </a:solidFill>
               </a:rPr>
-              <a:t>One SOW.</a:t>
+              <a:t>One SOW,</a:t>
             </a:r>
           </a:p>
           <a:p xmlns:a="http://schemas.openxmlformats.org/drawingml/2006/main">
@@ -1880,7 +1880,7 @@
                   <a:srgbClr val="12241C"/>
                 </a:solidFill>
               </a:rPr>
-              <a:t>Six criteria.</a:t>
+              <a:t>six clear checks,</a:t>
             </a:r>
           </a:p>
           <a:p xmlns:a="http://schemas.openxmlformats.org/drawingml/2006/main">
@@ -1898,7 +1898,7 @@
                   <a:srgbClr val="12241C"/>
                 </a:solidFill>
               </a:rPr>
-              <a:t>One proof chain.</a:t>
+              <a:t>one approval trail.</a:t>
             </a:r>
           </a:p>
         </p:txBody>
@@ -1920,7 +1920,7 @@
         <p:spPr>
           <a:xfrm xmlns:a="http://schemas.openxmlformats.org/drawingml/2006/main">
             <a:off x="8858250" y="4600575"/>
-            <a:ext cx="2524125" cy="28575"/>
+            <a:ext cx="2809875" cy="28575"/>
           </a:xfrm>
           <a:prstGeom xmlns:a="http://schemas.openxmlformats.org/drawingml/2006/main" prst="rect">
             <a:avLst/>
@@ -1953,7 +1953,7 @@
         <p:spPr>
           <a:xfrm xmlns:a="http://schemas.openxmlformats.org/drawingml/2006/main">
             <a:off x="8858250" y="4810125"/>
-            <a:ext cx="2524125" cy="304800"/>
+            <a:ext cx="2809875" cy="304800"/>
           </a:xfrm>
           <a:prstGeom xmlns:a="http://schemas.openxmlformats.org/drawingml/2006/main" prst="rect">
             <a:avLst/>
@@ -2164,7 +2164,7 @@
                   <a:srgbClr val="12241C"/>
                 </a:solidFill>
               </a:rPr>
-              <a:t>The work is done. The decision is still scattered.</a:t>
+              <a:t>The work may be finished, but the approval trail is scattered.</a:t>
             </a:r>
           </a:p>
         </p:txBody>
@@ -2350,7 +2350,7 @@
                   <a:srgbClr val="556159"/>
                 </a:solidFill>
               </a:rPr>
-              <a:t>The promise lives in a SOW.</a:t>
+              <a:t>The promise starts in the SOW.</a:t>
             </a:r>
           </a:p>
         </p:txBody>
@@ -2536,7 +2536,7 @@
                   <a:srgbClr val="556159"/>
                 </a:solidFill>
               </a:rPr>
-              <a:t>Screenshots and observations live somewhere else.</a:t>
+              <a:t>Screenshots and test results end up somewhere else.</a:t>
             </a:r>
           </a:p>
         </p:txBody>
@@ -2722,7 +2722,7 @@
                   <a:srgbClr val="556159"/>
                 </a:solidFill>
               </a:rPr>
-              <a:t>Approval gets buried in email or chat.</a:t>
+              <a:t>The approval gets buried in email or chat.</a:t>
             </a:r>
           </a:p>
         </p:txBody>
@@ -2908,7 +2908,7 @@
                   <a:srgbClr val="556159"/>
                 </a:solidFill>
               </a:rPr>
-              <a:t>The invoice handoff loses the evidence trail.</a:t>
+              <a:t>By invoicing time, the evidence trail is gone.</a:t>
             </a:r>
           </a:p>
         </p:txBody>
@@ -2929,8 +2929,8 @@
         </p:nvSpPr>
         <p:spPr>
           <a:xfrm xmlns:a="http://schemas.openxmlformats.org/drawingml/2006/main">
-            <a:off x="6858000" y="6029325"/>
-            <a:ext cx="4648200" cy="323850"/>
+            <a:off x="6858000" y="5886450"/>
+            <a:ext cx="4648200" cy="552450"/>
           </a:xfrm>
           <a:prstGeom xmlns:a="http://schemas.openxmlformats.org/drawingml/2006/main" prst="rect">
             <a:avLst/>
@@ -2959,7 +2959,7 @@
                   <a:srgbClr val="126B46"/>
                 </a:solidFill>
               </a:rPr>
-              <a:t>Greenlit’s job is to keep those four moments connected.</a:t>
+              <a:t>Greenlit keeps the promise, proof, decision, and invoice handoff together.</a:t>
             </a:r>
           </a:p>
         </p:txBody>
@@ -3112,7 +3112,7 @@
         <p:spPr>
           <a:xfrm xmlns:a="http://schemas.openxmlformats.org/drawingml/2006/main">
             <a:off x="685800" y="1000125"/>
-            <a:ext cx="9239250" cy="714375"/>
+            <a:ext cx="9239250" cy="1190625"/>
           </a:xfrm>
           <a:prstGeom xmlns:a="http://schemas.openxmlformats.org/drawingml/2006/main" prst="rect">
             <a:avLst/>
@@ -3141,7 +3141,7 @@
                   <a:srgbClr val="12241C"/>
                 </a:solidFill>
               </a:rPr>
-              <a:t>One evidence chain replaces the handoff gap.</a:t>
+              <a:t>The same promise stays connected from contract to approval.</a:t>
             </a:r>
           </a:p>
         </p:txBody>
@@ -3189,7 +3189,7 @@
             <a:r>
               <a:rPr sz="5250" b="0" i="0">
                 <a:solidFill>
-                  <a:srgbClr val="AFD12F"/>
+                  <a:srgbClr val="126B46"/>
                 </a:solidFill>
               </a:rPr>
               <a:t>1</a:t>
@@ -3215,6 +3215,852 @@
           <a:xfrm xmlns:a="http://schemas.openxmlformats.org/drawingml/2006/main">
             <a:off x="685800" y="3352800"/>
             <a:ext cx="2171700" cy="28575"/>
+          </a:xfrm>
+          <a:prstGeom xmlns:a="http://schemas.openxmlformats.org/drawingml/2006/main" prst="rect">
+            <a:avLst/>
+          </a:prstGeom>
+          <a:solidFill xmlns:a="http://schemas.openxmlformats.org/drawingml/2006/main">
+            <a:srgbClr val="126B46"/>
+          </a:solidFill>
+          <a:ln xmlns:a="http://schemas.openxmlformats.org/drawingml/2006/main" w="0">
+            <a:solidFill>
+              <a:srgbClr val="126B46"/>
+            </a:solidFill>
+            <a:prstDash val="solid"/>
+          </a:ln>
+        </p:spPr>
+      </p:sp>
+      <p:sp>
+        <p:nvSpPr>
+          <p:cNvPr id="6" name="">
+            <a:extLst xmlns:a="http://schemas.openxmlformats.org/drawingml/2006/main">
+              <a:ext uri="{FF2B5EF4-FFF2-40B4-BE49-F238E27FC236}">
+                <a16:creationId xmlns:a16="http://schemas.microsoft.com/office/drawing/2014/main" id="{136F349B-DE3E-4EA0-855F-8BE45AB738C7}"/>
+              </a:ext>
+            </a:extLst>
+          </p:cNvPr>
+          <p:cNvSpPr>
+            <a:spLocks xmlns:a="http://schemas.openxmlformats.org/drawingml/2006/main" noGrp="1"/>
+          </p:cNvSpPr>
+          <p:nvPr/>
+        </p:nvSpPr>
+        <p:spPr>
+          <a:xfrm xmlns:a="http://schemas.openxmlformats.org/drawingml/2006/main">
+            <a:off x="685800" y="3619500"/>
+            <a:ext cx="2095500" cy="381000"/>
+          </a:xfrm>
+          <a:prstGeom xmlns:a="http://schemas.openxmlformats.org/drawingml/2006/main" prst="rect">
+            <a:avLst/>
+          </a:prstGeom>
+          <a:noFill xmlns:a="http://schemas.openxmlformats.org/drawingml/2006/main"/>
+          <a:ln xmlns:a="http://schemas.openxmlformats.org/drawingml/2006/main" w="0">
+            <a:noFill/>
+            <a:prstDash val="solid"/>
+          </a:ln>
+        </p:spPr>
+        <p:txBody>
+          <a:bodyPr xmlns:a="http://schemas.openxmlformats.org/drawingml/2006/main" anchor="t"/>
+          <a:lstStyle xmlns:a="http://schemas.openxmlformats.org/drawingml/2006/main"/>
+          <a:p xmlns:a="http://schemas.openxmlformats.org/drawingml/2006/main">
+            <a:pPr algn="l">
+              <a:buNone/>
+              <a:defRPr sz="2025" b="1" i="0">
+                <a:solidFill>
+                  <a:srgbClr val="12241C"/>
+                </a:solidFill>
+              </a:defRPr>
+            </a:pPr>
+            <a:r>
+              <a:rPr sz="2025" b="1" i="0">
+                <a:solidFill>
+                  <a:srgbClr val="12241C"/>
+                </a:solidFill>
+              </a:rPr>
+              <a:t>Confirm</a:t>
+            </a:r>
+          </a:p>
+        </p:txBody>
+      </p:sp>
+      <p:sp>
+        <p:nvSpPr>
+          <p:cNvPr id="7" name="">
+            <a:extLst xmlns:a="http://schemas.openxmlformats.org/drawingml/2006/main">
+              <a:ext uri="{FF2B5EF4-FFF2-40B4-BE49-F238E27FC236}">
+                <a16:creationId xmlns:a16="http://schemas.microsoft.com/office/drawing/2014/main" id="{F819A960-81EB-441E-A44D-C1FE2E8D337C}"/>
+              </a:ext>
+            </a:extLst>
+          </p:cNvPr>
+          <p:cNvSpPr>
+            <a:spLocks xmlns:a="http://schemas.openxmlformats.org/drawingml/2006/main" noGrp="1"/>
+          </p:cNvSpPr>
+          <p:nvPr/>
+        </p:nvSpPr>
+        <p:spPr>
+          <a:xfrm xmlns:a="http://schemas.openxmlformats.org/drawingml/2006/main">
+            <a:off x="685800" y="4114800"/>
+            <a:ext cx="2171700" cy="1066800"/>
+          </a:xfrm>
+          <a:prstGeom xmlns:a="http://schemas.openxmlformats.org/drawingml/2006/main" prst="rect">
+            <a:avLst/>
+          </a:prstGeom>
+          <a:noFill xmlns:a="http://schemas.openxmlformats.org/drawingml/2006/main"/>
+          <a:ln xmlns:a="http://schemas.openxmlformats.org/drawingml/2006/main" w="0">
+            <a:noFill/>
+            <a:prstDash val="solid"/>
+          </a:ln>
+        </p:spPr>
+        <p:txBody>
+          <a:bodyPr xmlns:a="http://schemas.openxmlformats.org/drawingml/2006/main" anchor="t"/>
+          <a:lstStyle xmlns:a="http://schemas.openxmlformats.org/drawingml/2006/main"/>
+          <a:p xmlns:a="http://schemas.openxmlformats.org/drawingml/2006/main">
+            <a:pPr algn="l">
+              <a:buNone/>
+              <a:defRPr sz="1350" b="0" i="0">
+                <a:solidFill>
+                  <a:srgbClr val="556159"/>
+                </a:solidFill>
+              </a:defRPr>
+            </a:pPr>
+            <a:r>
+              <a:rPr sz="1350" b="0" i="0">
+                <a:solidFill>
+                  <a:srgbClr val="556159"/>
+                </a:solidFill>
+              </a:rPr>
+              <a:t>Turn the SOW into clear criteria your team approves.</a:t>
+            </a:r>
+          </a:p>
+        </p:txBody>
+      </p:sp>
+      <p:sp>
+        <p:nvSpPr>
+          <p:cNvPr id="8" name="">
+            <a:extLst xmlns:a="http://schemas.openxmlformats.org/drawingml/2006/main">
+              <a:ext uri="{FF2B5EF4-FFF2-40B4-BE49-F238E27FC236}">
+                <a16:creationId xmlns:a16="http://schemas.microsoft.com/office/drawing/2014/main" id="{013C3263-16D8-41B7-8DE6-451258E93CCC}"/>
+              </a:ext>
+            </a:extLst>
+          </p:cNvPr>
+          <p:cNvSpPr>
+            <a:spLocks xmlns:a="http://schemas.openxmlformats.org/drawingml/2006/main" noGrp="1"/>
+          </p:cNvSpPr>
+          <p:nvPr/>
+        </p:nvSpPr>
+        <p:spPr>
+          <a:xfrm xmlns:a="http://schemas.openxmlformats.org/drawingml/2006/main">
+            <a:off x="2933700" y="2857500"/>
+            <a:ext cx="381000" cy="457200"/>
+          </a:xfrm>
+          <a:prstGeom xmlns:a="http://schemas.openxmlformats.org/drawingml/2006/main" prst="rect">
+            <a:avLst/>
+          </a:prstGeom>
+          <a:noFill xmlns:a="http://schemas.openxmlformats.org/drawingml/2006/main"/>
+          <a:ln xmlns:a="http://schemas.openxmlformats.org/drawingml/2006/main" w="0">
+            <a:noFill/>
+            <a:prstDash val="solid"/>
+          </a:ln>
+        </p:spPr>
+        <p:txBody>
+          <a:bodyPr xmlns:a="http://schemas.openxmlformats.org/drawingml/2006/main" anchor="t"/>
+          <a:lstStyle xmlns:a="http://schemas.openxmlformats.org/drawingml/2006/main"/>
+          <a:p xmlns:a="http://schemas.openxmlformats.org/drawingml/2006/main">
+            <a:pPr algn="ctr">
+              <a:buNone/>
+              <a:defRPr sz="2400" b="1" i="0">
+                <a:solidFill>
+                  <a:srgbClr val="126B46"/>
+                </a:solidFill>
+              </a:defRPr>
+            </a:pPr>
+            <a:r>
+              <a:rPr sz="2400" b="1" i="0">
+                <a:solidFill>
+                  <a:srgbClr val="126B46"/>
+                </a:solidFill>
+              </a:rPr>
+              <a:t>→</a:t>
+            </a:r>
+          </a:p>
+        </p:txBody>
+      </p:sp>
+      <p:sp>
+        <p:nvSpPr>
+          <p:cNvPr id="9" name="">
+            <a:extLst xmlns:a="http://schemas.openxmlformats.org/drawingml/2006/main">
+              <a:ext uri="{FF2B5EF4-FFF2-40B4-BE49-F238E27FC236}">
+                <a16:creationId xmlns:a16="http://schemas.microsoft.com/office/drawing/2014/main" id="{2A1F5186-DE14-4D0C-A620-9DFA8814F16F}"/>
+              </a:ext>
+            </a:extLst>
+          </p:cNvPr>
+          <p:cNvSpPr>
+            <a:spLocks xmlns:a="http://schemas.openxmlformats.org/drawingml/2006/main" noGrp="1"/>
+          </p:cNvSpPr>
+          <p:nvPr/>
+        </p:nvSpPr>
+        <p:spPr>
+          <a:xfrm xmlns:a="http://schemas.openxmlformats.org/drawingml/2006/main">
+            <a:off x="3390900" y="2381250"/>
+            <a:ext cx="628650" cy="857250"/>
+          </a:xfrm>
+          <a:prstGeom xmlns:a="http://schemas.openxmlformats.org/drawingml/2006/main" prst="rect">
+            <a:avLst/>
+          </a:prstGeom>
+          <a:noFill xmlns:a="http://schemas.openxmlformats.org/drawingml/2006/main"/>
+          <a:ln xmlns:a="http://schemas.openxmlformats.org/drawingml/2006/main" w="0">
+            <a:noFill/>
+            <a:prstDash val="solid"/>
+          </a:ln>
+        </p:spPr>
+        <p:txBody>
+          <a:bodyPr xmlns:a="http://schemas.openxmlformats.org/drawingml/2006/main" anchor="t"/>
+          <a:lstStyle xmlns:a="http://schemas.openxmlformats.org/drawingml/2006/main"/>
+          <a:p xmlns:a="http://schemas.openxmlformats.org/drawingml/2006/main">
+            <a:pPr algn="l">
+              <a:buNone/>
+              <a:defRPr sz="5250" b="0" i="0">
+                <a:solidFill>
+                  <a:srgbClr val="AFD12F"/>
+                </a:solidFill>
+              </a:defRPr>
+            </a:pPr>
+            <a:r>
+              <a:rPr sz="5250" b="0" i="0">
+                <a:solidFill>
+                  <a:srgbClr val="126B46"/>
+                </a:solidFill>
+              </a:rPr>
+              <a:t>2</a:t>
+            </a:r>
+          </a:p>
+        </p:txBody>
+      </p:sp>
+      <p:sp>
+        <p:nvSpPr>
+          <p:cNvPr id="10" name="">
+            <a:extLst xmlns:a="http://schemas.openxmlformats.org/drawingml/2006/main">
+              <a:ext uri="{FF2B5EF4-FFF2-40B4-BE49-F238E27FC236}">
+                <a16:creationId xmlns:a16="http://schemas.microsoft.com/office/drawing/2014/main" id="{513F95F0-7B6E-4991-8A5F-1ED7228BBF1F}"/>
+              </a:ext>
+            </a:extLst>
+          </p:cNvPr>
+          <p:cNvSpPr>
+            <a:spLocks xmlns:a="http://schemas.openxmlformats.org/drawingml/2006/main" noGrp="1"/>
+          </p:cNvSpPr>
+          <p:nvPr/>
+        </p:nvSpPr>
+        <p:spPr>
+          <a:xfrm xmlns:a="http://schemas.openxmlformats.org/drawingml/2006/main">
+            <a:off x="3390900" y="3352800"/>
+            <a:ext cx="2171700" cy="28575"/>
+          </a:xfrm>
+          <a:prstGeom xmlns:a="http://schemas.openxmlformats.org/drawingml/2006/main" prst="rect">
+            <a:avLst/>
+          </a:prstGeom>
+          <a:solidFill xmlns:a="http://schemas.openxmlformats.org/drawingml/2006/main">
+            <a:srgbClr val="126B46"/>
+          </a:solidFill>
+          <a:ln xmlns:a="http://schemas.openxmlformats.org/drawingml/2006/main" w="0">
+            <a:solidFill>
+              <a:srgbClr val="126B46"/>
+            </a:solidFill>
+            <a:prstDash val="solid"/>
+          </a:ln>
+        </p:spPr>
+      </p:sp>
+      <p:sp>
+        <p:nvSpPr>
+          <p:cNvPr id="11" name="">
+            <a:extLst xmlns:a="http://schemas.openxmlformats.org/drawingml/2006/main">
+              <a:ext uri="{FF2B5EF4-FFF2-40B4-BE49-F238E27FC236}">
+                <a16:creationId xmlns:a16="http://schemas.microsoft.com/office/drawing/2014/main" id="{122137D4-5CC2-4DF0-86F7-314AAAC30B53}"/>
+              </a:ext>
+            </a:extLst>
+          </p:cNvPr>
+          <p:cNvSpPr>
+            <a:spLocks xmlns:a="http://schemas.openxmlformats.org/drawingml/2006/main" noGrp="1"/>
+          </p:cNvSpPr>
+          <p:nvPr/>
+        </p:nvSpPr>
+        <p:spPr>
+          <a:xfrm xmlns:a="http://schemas.openxmlformats.org/drawingml/2006/main">
+            <a:off x="3390900" y="3619500"/>
+            <a:ext cx="2095500" cy="381000"/>
+          </a:xfrm>
+          <a:prstGeom xmlns:a="http://schemas.openxmlformats.org/drawingml/2006/main" prst="rect">
+            <a:avLst/>
+          </a:prstGeom>
+          <a:noFill xmlns:a="http://schemas.openxmlformats.org/drawingml/2006/main"/>
+          <a:ln xmlns:a="http://schemas.openxmlformats.org/drawingml/2006/main" w="0">
+            <a:noFill/>
+            <a:prstDash val="solid"/>
+          </a:ln>
+        </p:spPr>
+        <p:txBody>
+          <a:bodyPr xmlns:a="http://schemas.openxmlformats.org/drawingml/2006/main" anchor="t"/>
+          <a:lstStyle xmlns:a="http://schemas.openxmlformats.org/drawingml/2006/main"/>
+          <a:p xmlns:a="http://schemas.openxmlformats.org/drawingml/2006/main">
+            <a:pPr algn="l">
+              <a:buNone/>
+              <a:defRPr sz="2025" b="1" i="0">
+                <a:solidFill>
+                  <a:srgbClr val="12241C"/>
+                </a:solidFill>
+              </a:defRPr>
+            </a:pPr>
+            <a:r>
+              <a:rPr sz="2025" b="1" i="0">
+                <a:solidFill>
+                  <a:srgbClr val="12241C"/>
+                </a:solidFill>
+              </a:rPr>
+              <a:t>Observe</a:t>
+            </a:r>
+          </a:p>
+        </p:txBody>
+      </p:sp>
+      <p:sp>
+        <p:nvSpPr>
+          <p:cNvPr id="12" name="">
+            <a:extLst xmlns:a="http://schemas.openxmlformats.org/drawingml/2006/main">
+              <a:ext uri="{FF2B5EF4-FFF2-40B4-BE49-F238E27FC236}">
+                <a16:creationId xmlns:a16="http://schemas.microsoft.com/office/drawing/2014/main" id="{A028D5A6-40C8-45DC-857C-E4D84A8F93B2}"/>
+              </a:ext>
+            </a:extLst>
+          </p:cNvPr>
+          <p:cNvSpPr>
+            <a:spLocks xmlns:a="http://schemas.openxmlformats.org/drawingml/2006/main" noGrp="1"/>
+          </p:cNvSpPr>
+          <p:nvPr/>
+        </p:nvSpPr>
+        <p:spPr>
+          <a:xfrm xmlns:a="http://schemas.openxmlformats.org/drawingml/2006/main">
+            <a:off x="3390900" y="4114800"/>
+            <a:ext cx="2171700" cy="1066800"/>
+          </a:xfrm>
+          <a:prstGeom xmlns:a="http://schemas.openxmlformats.org/drawingml/2006/main" prst="rect">
+            <a:avLst/>
+          </a:prstGeom>
+          <a:noFill xmlns:a="http://schemas.openxmlformats.org/drawingml/2006/main"/>
+          <a:ln xmlns:a="http://schemas.openxmlformats.org/drawingml/2006/main" w="0">
+            <a:noFill/>
+            <a:prstDash val="solid"/>
+          </a:ln>
+        </p:spPr>
+        <p:txBody>
+          <a:bodyPr xmlns:a="http://schemas.openxmlformats.org/drawingml/2006/main" anchor="t"/>
+          <a:lstStyle xmlns:a="http://schemas.openxmlformats.org/drawingml/2006/main"/>
+          <a:p xmlns:a="http://schemas.openxmlformats.org/drawingml/2006/main">
+            <a:pPr algn="l">
+              <a:buNone/>
+              <a:defRPr sz="1350" b="0" i="0">
+                <a:solidFill>
+                  <a:srgbClr val="556159"/>
+                </a:solidFill>
+              </a:defRPr>
+            </a:pPr>
+            <a:r>
+              <a:rPr sz="1350" b="0" i="0">
+                <a:solidFill>
+                  <a:srgbClr val="556159"/>
+                </a:solidFill>
+              </a:rPr>
+              <a:t>Run typed browser checks against the approved staging build.</a:t>
+            </a:r>
+          </a:p>
+        </p:txBody>
+      </p:sp>
+      <p:sp>
+        <p:nvSpPr>
+          <p:cNvPr id="13" name="">
+            <a:extLst xmlns:a="http://schemas.openxmlformats.org/drawingml/2006/main">
+              <a:ext uri="{FF2B5EF4-FFF2-40B4-BE49-F238E27FC236}">
+                <a16:creationId xmlns:a16="http://schemas.microsoft.com/office/drawing/2014/main" id="{AFFDCF95-5DEE-4FE8-905E-D1132BB52D0C}"/>
+              </a:ext>
+            </a:extLst>
+          </p:cNvPr>
+          <p:cNvSpPr>
+            <a:spLocks xmlns:a="http://schemas.openxmlformats.org/drawingml/2006/main" noGrp="1"/>
+          </p:cNvSpPr>
+          <p:nvPr/>
+        </p:nvSpPr>
+        <p:spPr>
+          <a:xfrm xmlns:a="http://schemas.openxmlformats.org/drawingml/2006/main">
+            <a:off x="5638800" y="2857500"/>
+            <a:ext cx="381000" cy="457200"/>
+          </a:xfrm>
+          <a:prstGeom xmlns:a="http://schemas.openxmlformats.org/drawingml/2006/main" prst="rect">
+            <a:avLst/>
+          </a:prstGeom>
+          <a:noFill xmlns:a="http://schemas.openxmlformats.org/drawingml/2006/main"/>
+          <a:ln xmlns:a="http://schemas.openxmlformats.org/drawingml/2006/main" w="0">
+            <a:noFill/>
+            <a:prstDash val="solid"/>
+          </a:ln>
+        </p:spPr>
+        <p:txBody>
+          <a:bodyPr xmlns:a="http://schemas.openxmlformats.org/drawingml/2006/main" anchor="t"/>
+          <a:lstStyle xmlns:a="http://schemas.openxmlformats.org/drawingml/2006/main"/>
+          <a:p xmlns:a="http://schemas.openxmlformats.org/drawingml/2006/main">
+            <a:pPr algn="ctr">
+              <a:buNone/>
+              <a:defRPr sz="2400" b="1" i="0">
+                <a:solidFill>
+                  <a:srgbClr val="126B46"/>
+                </a:solidFill>
+              </a:defRPr>
+            </a:pPr>
+            <a:r>
+              <a:rPr sz="2400" b="1" i="0">
+                <a:solidFill>
+                  <a:srgbClr val="126B46"/>
+                </a:solidFill>
+              </a:rPr>
+              <a:t>→</a:t>
+            </a:r>
+          </a:p>
+        </p:txBody>
+      </p:sp>
+      <p:sp>
+        <p:nvSpPr>
+          <p:cNvPr id="14" name="">
+            <a:extLst xmlns:a="http://schemas.openxmlformats.org/drawingml/2006/main">
+              <a:ext uri="{FF2B5EF4-FFF2-40B4-BE49-F238E27FC236}">
+                <a16:creationId xmlns:a16="http://schemas.microsoft.com/office/drawing/2014/main" id="{98052F4F-98AA-4C1D-A8E4-D9B5EC0057EF}"/>
+              </a:ext>
+            </a:extLst>
+          </p:cNvPr>
+          <p:cNvSpPr>
+            <a:spLocks xmlns:a="http://schemas.openxmlformats.org/drawingml/2006/main" noGrp="1"/>
+          </p:cNvSpPr>
+          <p:nvPr/>
+        </p:nvSpPr>
+        <p:spPr>
+          <a:xfrm xmlns:a="http://schemas.openxmlformats.org/drawingml/2006/main">
+            <a:off x="6096000" y="2381250"/>
+            <a:ext cx="628650" cy="857250"/>
+          </a:xfrm>
+          <a:prstGeom xmlns:a="http://schemas.openxmlformats.org/drawingml/2006/main" prst="rect">
+            <a:avLst/>
+          </a:prstGeom>
+          <a:noFill xmlns:a="http://schemas.openxmlformats.org/drawingml/2006/main"/>
+          <a:ln xmlns:a="http://schemas.openxmlformats.org/drawingml/2006/main" w="0">
+            <a:noFill/>
+            <a:prstDash val="solid"/>
+          </a:ln>
+        </p:spPr>
+        <p:txBody>
+          <a:bodyPr xmlns:a="http://schemas.openxmlformats.org/drawingml/2006/main" anchor="t"/>
+          <a:lstStyle xmlns:a="http://schemas.openxmlformats.org/drawingml/2006/main"/>
+          <a:p xmlns:a="http://schemas.openxmlformats.org/drawingml/2006/main">
+            <a:pPr algn="l">
+              <a:buNone/>
+              <a:defRPr sz="5250" b="0" i="0">
+                <a:solidFill>
+                  <a:srgbClr val="126B46"/>
+                </a:solidFill>
+              </a:defRPr>
+            </a:pPr>
+            <a:r>
+              <a:rPr sz="5250" b="0" i="0">
+                <a:solidFill>
+                  <a:srgbClr val="126B46"/>
+                </a:solidFill>
+              </a:rPr>
+              <a:t>3</a:t>
+            </a:r>
+          </a:p>
+        </p:txBody>
+      </p:sp>
+      <p:sp>
+        <p:nvSpPr>
+          <p:cNvPr id="15" name="">
+            <a:extLst xmlns:a="http://schemas.openxmlformats.org/drawingml/2006/main">
+              <a:ext uri="{FF2B5EF4-FFF2-40B4-BE49-F238E27FC236}">
+                <a16:creationId xmlns:a16="http://schemas.microsoft.com/office/drawing/2014/main" id="{DCBAF01D-4D3B-4556-8E45-A0C7938B81D5}"/>
+              </a:ext>
+            </a:extLst>
+          </p:cNvPr>
+          <p:cNvSpPr>
+            <a:spLocks xmlns:a="http://schemas.openxmlformats.org/drawingml/2006/main" noGrp="1"/>
+          </p:cNvSpPr>
+          <p:nvPr/>
+        </p:nvSpPr>
+        <p:spPr>
+          <a:xfrm xmlns:a="http://schemas.openxmlformats.org/drawingml/2006/main">
+            <a:off x="6096000" y="3352800"/>
+            <a:ext cx="2171700" cy="28575"/>
+          </a:xfrm>
+          <a:prstGeom xmlns:a="http://schemas.openxmlformats.org/drawingml/2006/main" prst="rect">
+            <a:avLst/>
+          </a:prstGeom>
+          <a:solidFill xmlns:a="http://schemas.openxmlformats.org/drawingml/2006/main">
+            <a:srgbClr val="126B46"/>
+          </a:solidFill>
+          <a:ln xmlns:a="http://schemas.openxmlformats.org/drawingml/2006/main" w="0">
+            <a:solidFill>
+              <a:srgbClr val="126B46"/>
+            </a:solidFill>
+            <a:prstDash val="solid"/>
+          </a:ln>
+        </p:spPr>
+      </p:sp>
+      <p:sp>
+        <p:nvSpPr>
+          <p:cNvPr id="16" name="">
+            <a:extLst xmlns:a="http://schemas.openxmlformats.org/drawingml/2006/main">
+              <a:ext uri="{FF2B5EF4-FFF2-40B4-BE49-F238E27FC236}">
+                <a16:creationId xmlns:a16="http://schemas.microsoft.com/office/drawing/2014/main" id="{C467E517-4EFA-4EBE-971E-A873FE666CCB}"/>
+              </a:ext>
+            </a:extLst>
+          </p:cNvPr>
+          <p:cNvSpPr>
+            <a:spLocks xmlns:a="http://schemas.openxmlformats.org/drawingml/2006/main" noGrp="1"/>
+          </p:cNvSpPr>
+          <p:nvPr/>
+        </p:nvSpPr>
+        <p:spPr>
+          <a:xfrm xmlns:a="http://schemas.openxmlformats.org/drawingml/2006/main">
+            <a:off x="6096000" y="3619500"/>
+            <a:ext cx="2095500" cy="381000"/>
+          </a:xfrm>
+          <a:prstGeom xmlns:a="http://schemas.openxmlformats.org/drawingml/2006/main" prst="rect">
+            <a:avLst/>
+          </a:prstGeom>
+          <a:noFill xmlns:a="http://schemas.openxmlformats.org/drawingml/2006/main"/>
+          <a:ln xmlns:a="http://schemas.openxmlformats.org/drawingml/2006/main" w="0">
+            <a:noFill/>
+            <a:prstDash val="solid"/>
+          </a:ln>
+        </p:spPr>
+        <p:txBody>
+          <a:bodyPr xmlns:a="http://schemas.openxmlformats.org/drawingml/2006/main" anchor="t"/>
+          <a:lstStyle xmlns:a="http://schemas.openxmlformats.org/drawingml/2006/main"/>
+          <a:p xmlns:a="http://schemas.openxmlformats.org/drawingml/2006/main">
+            <a:pPr algn="l">
+              <a:buNone/>
+              <a:defRPr sz="2025" b="1" i="0">
+                <a:solidFill>
+                  <a:srgbClr val="12241C"/>
+                </a:solidFill>
+              </a:defRPr>
+            </a:pPr>
+            <a:r>
+              <a:rPr sz="2025" b="1" i="0">
+                <a:solidFill>
+                  <a:srgbClr val="12241C"/>
+                </a:solidFill>
+              </a:rPr>
+              <a:t>Decide</a:t>
+            </a:r>
+          </a:p>
+        </p:txBody>
+      </p:sp>
+      <p:sp>
+        <p:nvSpPr>
+          <p:cNvPr id="17" name="">
+            <a:extLst xmlns:a="http://schemas.openxmlformats.org/drawingml/2006/main">
+              <a:ext uri="{FF2B5EF4-FFF2-40B4-BE49-F238E27FC236}">
+                <a16:creationId xmlns:a16="http://schemas.microsoft.com/office/drawing/2014/main" id="{39C04965-C345-4364-8DE5-EC23C2A41C6C}"/>
+              </a:ext>
+            </a:extLst>
+          </p:cNvPr>
+          <p:cNvSpPr>
+            <a:spLocks xmlns:a="http://schemas.openxmlformats.org/drawingml/2006/main" noGrp="1"/>
+          </p:cNvSpPr>
+          <p:nvPr/>
+        </p:nvSpPr>
+        <p:spPr>
+          <a:xfrm xmlns:a="http://schemas.openxmlformats.org/drawingml/2006/main">
+            <a:off x="6096000" y="4114800"/>
+            <a:ext cx="2171700" cy="1066800"/>
+          </a:xfrm>
+          <a:prstGeom xmlns:a="http://schemas.openxmlformats.org/drawingml/2006/main" prst="rect">
+            <a:avLst/>
+          </a:prstGeom>
+          <a:noFill xmlns:a="http://schemas.openxmlformats.org/drawingml/2006/main"/>
+          <a:ln xmlns:a="http://schemas.openxmlformats.org/drawingml/2006/main" w="0">
+            <a:noFill/>
+            <a:prstDash val="solid"/>
+          </a:ln>
+        </p:spPr>
+        <p:txBody>
+          <a:bodyPr xmlns:a="http://schemas.openxmlformats.org/drawingml/2006/main" anchor="t"/>
+          <a:lstStyle xmlns:a="http://schemas.openxmlformats.org/drawingml/2006/main"/>
+          <a:p xmlns:a="http://schemas.openxmlformats.org/drawingml/2006/main">
+            <a:pPr algn="l">
+              <a:buNone/>
+              <a:defRPr sz="1350" b="0" i="0">
+                <a:solidFill>
+                  <a:srgbClr val="556159"/>
+                </a:solidFill>
+              </a:defRPr>
+            </a:pPr>
+            <a:r>
+              <a:rPr sz="1350" b="0" i="0">
+                <a:solidFill>
+                  <a:srgbClr val="556159"/>
+                </a:solidFill>
+              </a:rPr>
+              <a:t>Give one reviewer the promise, result, evidence, and deadline.</a:t>
+            </a:r>
+          </a:p>
+        </p:txBody>
+      </p:sp>
+      <p:sp>
+        <p:nvSpPr>
+          <p:cNvPr id="18" name="">
+            <a:extLst xmlns:a="http://schemas.openxmlformats.org/drawingml/2006/main">
+              <a:ext uri="{FF2B5EF4-FFF2-40B4-BE49-F238E27FC236}">
+                <a16:creationId xmlns:a16="http://schemas.microsoft.com/office/drawing/2014/main" id="{52EE9594-0759-4C30-B2D5-88747D30C22A}"/>
+              </a:ext>
+            </a:extLst>
+          </p:cNvPr>
+          <p:cNvSpPr>
+            <a:spLocks xmlns:a="http://schemas.openxmlformats.org/drawingml/2006/main" noGrp="1"/>
+          </p:cNvSpPr>
+          <p:nvPr/>
+        </p:nvSpPr>
+        <p:spPr>
+          <a:xfrm xmlns:a="http://schemas.openxmlformats.org/drawingml/2006/main">
+            <a:off x="8343900" y="2857500"/>
+            <a:ext cx="381000" cy="457200"/>
+          </a:xfrm>
+          <a:prstGeom xmlns:a="http://schemas.openxmlformats.org/drawingml/2006/main" prst="rect">
+            <a:avLst/>
+          </a:prstGeom>
+          <a:noFill xmlns:a="http://schemas.openxmlformats.org/drawingml/2006/main"/>
+          <a:ln xmlns:a="http://schemas.openxmlformats.org/drawingml/2006/main" w="0">
+            <a:noFill/>
+            <a:prstDash val="solid"/>
+          </a:ln>
+        </p:spPr>
+        <p:txBody>
+          <a:bodyPr xmlns:a="http://schemas.openxmlformats.org/drawingml/2006/main" anchor="t"/>
+          <a:lstStyle xmlns:a="http://schemas.openxmlformats.org/drawingml/2006/main"/>
+          <a:p xmlns:a="http://schemas.openxmlformats.org/drawingml/2006/main">
+            <a:pPr algn="ctr">
+              <a:buNone/>
+              <a:defRPr sz="2400" b="1" i="0">
+                <a:solidFill>
+                  <a:srgbClr val="126B46"/>
+                </a:solidFill>
+              </a:defRPr>
+            </a:pPr>
+            <a:r>
+              <a:rPr sz="2400" b="1" i="0">
+                <a:solidFill>
+                  <a:srgbClr val="126B46"/>
+                </a:solidFill>
+              </a:rPr>
+              <a:t>→</a:t>
+            </a:r>
+          </a:p>
+        </p:txBody>
+      </p:sp>
+      <p:sp>
+        <p:nvSpPr>
+          <p:cNvPr id="19" name="">
+            <a:extLst xmlns:a="http://schemas.openxmlformats.org/drawingml/2006/main">
+              <a:ext uri="{FF2B5EF4-FFF2-40B4-BE49-F238E27FC236}">
+                <a16:creationId xmlns:a16="http://schemas.microsoft.com/office/drawing/2014/main" id="{0157D690-D188-4A5C-B2F2-7141C6898C38}"/>
+              </a:ext>
+            </a:extLst>
+          </p:cNvPr>
+          <p:cNvSpPr>
+            <a:spLocks xmlns:a="http://schemas.openxmlformats.org/drawingml/2006/main" noGrp="1"/>
+          </p:cNvSpPr>
+          <p:nvPr/>
+        </p:nvSpPr>
+        <p:spPr>
+          <a:xfrm xmlns:a="http://schemas.openxmlformats.org/drawingml/2006/main">
+            <a:off x="8801100" y="2381250"/>
+            <a:ext cx="628650" cy="857250"/>
+          </a:xfrm>
+          <a:prstGeom xmlns:a="http://schemas.openxmlformats.org/drawingml/2006/main" prst="rect">
+            <a:avLst/>
+          </a:prstGeom>
+          <a:noFill xmlns:a="http://schemas.openxmlformats.org/drawingml/2006/main"/>
+          <a:ln xmlns:a="http://schemas.openxmlformats.org/drawingml/2006/main" w="0">
+            <a:noFill/>
+            <a:prstDash val="solid"/>
+          </a:ln>
+        </p:spPr>
+        <p:txBody>
+          <a:bodyPr xmlns:a="http://schemas.openxmlformats.org/drawingml/2006/main" anchor="t"/>
+          <a:lstStyle xmlns:a="http://schemas.openxmlformats.org/drawingml/2006/main"/>
+          <a:p xmlns:a="http://schemas.openxmlformats.org/drawingml/2006/main">
+            <a:pPr algn="l">
+              <a:buNone/>
+              <a:defRPr sz="5250" b="0" i="0">
+                <a:solidFill>
+                  <a:srgbClr val="AFD12F"/>
+                </a:solidFill>
+              </a:defRPr>
+            </a:pPr>
+            <a:r>
+              <a:rPr sz="5250" b="0" i="0">
+                <a:solidFill>
+                  <a:srgbClr val="126B46"/>
+                </a:solidFill>
+              </a:rPr>
+              <a:t>4</a:t>
+            </a:r>
+          </a:p>
+        </p:txBody>
+      </p:sp>
+      <p:sp>
+        <p:nvSpPr>
+          <p:cNvPr id="20" name="">
+            <a:extLst xmlns:a="http://schemas.openxmlformats.org/drawingml/2006/main">
+              <a:ext uri="{FF2B5EF4-FFF2-40B4-BE49-F238E27FC236}">
+                <a16:creationId xmlns:a16="http://schemas.microsoft.com/office/drawing/2014/main" id="{3B6D7763-A013-4F85-A5DB-2A242BCF820C}"/>
+              </a:ext>
+            </a:extLst>
+          </p:cNvPr>
+          <p:cNvSpPr>
+            <a:spLocks xmlns:a="http://schemas.openxmlformats.org/drawingml/2006/main" noGrp="1"/>
+          </p:cNvSpPr>
+          <p:nvPr/>
+        </p:nvSpPr>
+        <p:spPr>
+          <a:xfrm xmlns:a="http://schemas.openxmlformats.org/drawingml/2006/main">
+            <a:off x="8801100" y="3352800"/>
+            <a:ext cx="2171700" cy="28575"/>
+          </a:xfrm>
+          <a:prstGeom xmlns:a="http://schemas.openxmlformats.org/drawingml/2006/main" prst="rect">
+            <a:avLst/>
+          </a:prstGeom>
+          <a:solidFill xmlns:a="http://schemas.openxmlformats.org/drawingml/2006/main">
+            <a:srgbClr val="126B46"/>
+          </a:solidFill>
+          <a:ln xmlns:a="http://schemas.openxmlformats.org/drawingml/2006/main" w="0">
+            <a:solidFill>
+              <a:srgbClr val="126B46"/>
+            </a:solidFill>
+            <a:prstDash val="solid"/>
+          </a:ln>
+        </p:spPr>
+      </p:sp>
+      <p:sp>
+        <p:nvSpPr>
+          <p:cNvPr id="21" name="">
+            <a:extLst xmlns:a="http://schemas.openxmlformats.org/drawingml/2006/main">
+              <a:ext uri="{FF2B5EF4-FFF2-40B4-BE49-F238E27FC236}">
+                <a16:creationId xmlns:a16="http://schemas.microsoft.com/office/drawing/2014/main" id="{78F0E32D-497C-4195-A7B8-6C1DFABB3EAC}"/>
+              </a:ext>
+            </a:extLst>
+          </p:cNvPr>
+          <p:cNvSpPr>
+            <a:spLocks xmlns:a="http://schemas.openxmlformats.org/drawingml/2006/main" noGrp="1"/>
+          </p:cNvSpPr>
+          <p:nvPr/>
+        </p:nvSpPr>
+        <p:spPr>
+          <a:xfrm xmlns:a="http://schemas.openxmlformats.org/drawingml/2006/main">
+            <a:off x="8801100" y="3619500"/>
+            <a:ext cx="2095500" cy="381000"/>
+          </a:xfrm>
+          <a:prstGeom xmlns:a="http://schemas.openxmlformats.org/drawingml/2006/main" prst="rect">
+            <a:avLst/>
+          </a:prstGeom>
+          <a:noFill xmlns:a="http://schemas.openxmlformats.org/drawingml/2006/main"/>
+          <a:ln xmlns:a="http://schemas.openxmlformats.org/drawingml/2006/main" w="0">
+            <a:noFill/>
+            <a:prstDash val="solid"/>
+          </a:ln>
+        </p:spPr>
+        <p:txBody>
+          <a:bodyPr xmlns:a="http://schemas.openxmlformats.org/drawingml/2006/main" anchor="t"/>
+          <a:lstStyle xmlns:a="http://schemas.openxmlformats.org/drawingml/2006/main"/>
+          <a:p xmlns:a="http://schemas.openxmlformats.org/drawingml/2006/main">
+            <a:pPr algn="l">
+              <a:buNone/>
+              <a:defRPr sz="2025" b="1" i="0">
+                <a:solidFill>
+                  <a:srgbClr val="12241C"/>
+                </a:solidFill>
+              </a:defRPr>
+            </a:pPr>
+            <a:r>
+              <a:rPr sz="2025" b="1" i="0">
+                <a:solidFill>
+                  <a:srgbClr val="12241C"/>
+                </a:solidFill>
+              </a:rPr>
+              <a:t>Record</a:t>
+            </a:r>
+          </a:p>
+        </p:txBody>
+      </p:sp>
+      <p:sp>
+        <p:nvSpPr>
+          <p:cNvPr id="22" name="">
+            <a:extLst xmlns:a="http://schemas.openxmlformats.org/drawingml/2006/main">
+              <a:ext uri="{FF2B5EF4-FFF2-40B4-BE49-F238E27FC236}">
+                <a16:creationId xmlns:a16="http://schemas.microsoft.com/office/drawing/2014/main" id="{6FFC8E4E-B29E-41AB-9FED-83725DB4D9F2}"/>
+              </a:ext>
+            </a:extLst>
+          </p:cNvPr>
+          <p:cNvSpPr>
+            <a:spLocks xmlns:a="http://schemas.openxmlformats.org/drawingml/2006/main" noGrp="1"/>
+          </p:cNvSpPr>
+          <p:nvPr/>
+        </p:nvSpPr>
+        <p:spPr>
+          <a:xfrm xmlns:a="http://schemas.openxmlformats.org/drawingml/2006/main">
+            <a:off x="8801100" y="4114800"/>
+            <a:ext cx="2171700" cy="1066800"/>
+          </a:xfrm>
+          <a:prstGeom xmlns:a="http://schemas.openxmlformats.org/drawingml/2006/main" prst="rect">
+            <a:avLst/>
+          </a:prstGeom>
+          <a:noFill xmlns:a="http://schemas.openxmlformats.org/drawingml/2006/main"/>
+          <a:ln xmlns:a="http://schemas.openxmlformats.org/drawingml/2006/main" w="0">
+            <a:noFill/>
+            <a:prstDash val="solid"/>
+          </a:ln>
+        </p:spPr>
+        <p:txBody>
+          <a:bodyPr xmlns:a="http://schemas.openxmlformats.org/drawingml/2006/main" anchor="t"/>
+          <a:lstStyle xmlns:a="http://schemas.openxmlformats.org/drawingml/2006/main"/>
+          <a:p xmlns:a="http://schemas.openxmlformats.org/drawingml/2006/main">
+            <a:pPr algn="l">
+              <a:buNone/>
+              <a:defRPr sz="1350" b="0" i="0">
+                <a:solidFill>
+                  <a:srgbClr val="556159"/>
+                </a:solidFill>
+              </a:defRPr>
+            </a:pPr>
+            <a:r>
+              <a:rPr sz="1350" b="0" i="0">
+                <a:solidFill>
+                  <a:srgbClr val="556159"/>
+                </a:solidFill>
+              </a:rPr>
+              <a:t>Keep the decision with the details needed for invoicing.</a:t>
+            </a:r>
+          </a:p>
+        </p:txBody>
+      </p:sp>
+      <p:sp>
+        <p:nvSpPr>
+          <p:cNvPr id="23" name="">
+            <a:extLst xmlns:a="http://schemas.openxmlformats.org/drawingml/2006/main">
+              <a:ext uri="{FF2B5EF4-FFF2-40B4-BE49-F238E27FC236}">
+                <a16:creationId xmlns:a16="http://schemas.microsoft.com/office/drawing/2014/main" id="{CF40982D-6FF5-4C5D-B701-2CFD04F0C00E}"/>
+              </a:ext>
+            </a:extLst>
+          </p:cNvPr>
+          <p:cNvSpPr>
+            <a:spLocks xmlns:a="http://schemas.openxmlformats.org/drawingml/2006/main" noGrp="1"/>
+          </p:cNvSpPr>
+          <p:nvPr/>
+        </p:nvSpPr>
+        <p:spPr>
+          <a:xfrm xmlns:a="http://schemas.openxmlformats.org/drawingml/2006/main">
+            <a:off x="685800" y="5686425"/>
+            <a:ext cx="10820400" cy="581025"/>
           </a:xfrm>
           <a:prstGeom xmlns:a="http://schemas.openxmlformats.org/drawingml/2006/main" prst="rect">
             <a:avLst/>
@@ -3232,124 +4078,22 @@
       </p:sp>
       <p:sp>
         <p:nvSpPr>
-          <p:cNvPr id="6" name="">
-            <a:extLst xmlns:a="http://schemas.openxmlformats.org/drawingml/2006/main">
-              <a:ext uri="{FF2B5EF4-FFF2-40B4-BE49-F238E27FC236}">
-                <a16:creationId xmlns:a16="http://schemas.microsoft.com/office/drawing/2014/main" id="{136F349B-DE3E-4EA0-855F-8BE45AB738C7}"/>
-              </a:ext>
-            </a:extLst>
-          </p:cNvPr>
-          <p:cNvSpPr>
-            <a:spLocks xmlns:a="http://schemas.openxmlformats.org/drawingml/2006/main" noGrp="1"/>
-          </p:cNvSpPr>
-          <p:nvPr/>
-        </p:nvSpPr>
-        <p:spPr>
-          <a:xfrm xmlns:a="http://schemas.openxmlformats.org/drawingml/2006/main">
-            <a:off x="685800" y="3619500"/>
-            <a:ext cx="2095500" cy="381000"/>
-          </a:xfrm>
-          <a:prstGeom xmlns:a="http://schemas.openxmlformats.org/drawingml/2006/main" prst="rect">
-            <a:avLst/>
-          </a:prstGeom>
-          <a:noFill xmlns:a="http://schemas.openxmlformats.org/drawingml/2006/main"/>
-          <a:ln xmlns:a="http://schemas.openxmlformats.org/drawingml/2006/main" w="0">
-            <a:noFill/>
-            <a:prstDash val="solid"/>
-          </a:ln>
-        </p:spPr>
-        <p:txBody>
-          <a:bodyPr xmlns:a="http://schemas.openxmlformats.org/drawingml/2006/main" anchor="t"/>
-          <a:lstStyle xmlns:a="http://schemas.openxmlformats.org/drawingml/2006/main"/>
-          <a:p xmlns:a="http://schemas.openxmlformats.org/drawingml/2006/main">
-            <a:pPr algn="l">
-              <a:buNone/>
-              <a:defRPr sz="2025" b="1" i="0">
-                <a:solidFill>
-                  <a:srgbClr val="12241C"/>
-                </a:solidFill>
-              </a:defRPr>
-            </a:pPr>
-            <a:r>
-              <a:rPr sz="2025" b="1" i="0">
-                <a:solidFill>
-                  <a:srgbClr val="12241C"/>
-                </a:solidFill>
-              </a:rPr>
-              <a:t>Confirm</a:t>
-            </a:r>
-          </a:p>
-        </p:txBody>
-      </p:sp>
-      <p:sp>
-        <p:nvSpPr>
-          <p:cNvPr id="7" name="">
-            <a:extLst xmlns:a="http://schemas.openxmlformats.org/drawingml/2006/main">
-              <a:ext uri="{FF2B5EF4-FFF2-40B4-BE49-F238E27FC236}">
-                <a16:creationId xmlns:a16="http://schemas.microsoft.com/office/drawing/2014/main" id="{F819A960-81EB-441E-A44D-C1FE2E8D337C}"/>
-              </a:ext>
-            </a:extLst>
-          </p:cNvPr>
-          <p:cNvSpPr>
-            <a:spLocks xmlns:a="http://schemas.openxmlformats.org/drawingml/2006/main" noGrp="1"/>
-          </p:cNvSpPr>
-          <p:nvPr/>
-        </p:nvSpPr>
-        <p:spPr>
-          <a:xfrm xmlns:a="http://schemas.openxmlformats.org/drawingml/2006/main">
-            <a:off x="685800" y="4114800"/>
-            <a:ext cx="2171700" cy="1066800"/>
-          </a:xfrm>
-          <a:prstGeom xmlns:a="http://schemas.openxmlformats.org/drawingml/2006/main" prst="rect">
-            <a:avLst/>
-          </a:prstGeom>
-          <a:noFill xmlns:a="http://schemas.openxmlformats.org/drawingml/2006/main"/>
-          <a:ln xmlns:a="http://schemas.openxmlformats.org/drawingml/2006/main" w="0">
-            <a:noFill/>
-            <a:prstDash val="solid"/>
-          </a:ln>
-        </p:spPr>
-        <p:txBody>
-          <a:bodyPr xmlns:a="http://schemas.openxmlformats.org/drawingml/2006/main" anchor="t"/>
-          <a:lstStyle xmlns:a="http://schemas.openxmlformats.org/drawingml/2006/main"/>
-          <a:p xmlns:a="http://schemas.openxmlformats.org/drawingml/2006/main">
-            <a:pPr algn="l">
-              <a:buNone/>
-              <a:defRPr sz="1350" b="0" i="0">
-                <a:solidFill>
-                  <a:srgbClr val="556159"/>
-                </a:solidFill>
-              </a:defRPr>
-            </a:pPr>
-            <a:r>
-              <a:rPr sz="1350" b="0" i="0">
-                <a:solidFill>
-                  <a:srgbClr val="556159"/>
-                </a:solidFill>
-              </a:rPr>
-              <a:t>Exact SOW language becomes human-confirmed acceptance criteria.</a:t>
-            </a:r>
-          </a:p>
-        </p:txBody>
-      </p:sp>
-      <p:sp>
-        <p:nvSpPr>
-          <p:cNvPr id="8" name="">
-            <a:extLst xmlns:a="http://schemas.openxmlformats.org/drawingml/2006/main">
-              <a:ext uri="{FF2B5EF4-FFF2-40B4-BE49-F238E27FC236}">
-                <a16:creationId xmlns:a16="http://schemas.microsoft.com/office/drawing/2014/main" id="{013C3263-16D8-41B7-8DE6-451258E93CCC}"/>
-              </a:ext>
-            </a:extLst>
-          </p:cNvPr>
-          <p:cNvSpPr>
-            <a:spLocks xmlns:a="http://schemas.openxmlformats.org/drawingml/2006/main" noGrp="1"/>
-          </p:cNvSpPr>
-          <p:nvPr/>
-        </p:nvSpPr>
-        <p:spPr>
-          <a:xfrm xmlns:a="http://schemas.openxmlformats.org/drawingml/2006/main">
-            <a:off x="2933700" y="2857500"/>
-            <a:ext cx="381000" cy="457200"/>
+          <p:cNvPr id="24" name="">
+            <a:extLst xmlns:a="http://schemas.openxmlformats.org/drawingml/2006/main">
+              <a:ext uri="{FF2B5EF4-FFF2-40B4-BE49-F238E27FC236}">
+                <a16:creationId xmlns:a16="http://schemas.microsoft.com/office/drawing/2014/main" id="{CB057C7D-F805-4BE3-BD1A-10BDD9F5CF0C}"/>
+              </a:ext>
+            </a:extLst>
+          </p:cNvPr>
+          <p:cNvSpPr>
+            <a:spLocks xmlns:a="http://schemas.openxmlformats.org/drawingml/2006/main" noGrp="1"/>
+          </p:cNvSpPr>
+          <p:nvPr/>
+        </p:nvSpPr>
+        <p:spPr>
+          <a:xfrm xmlns:a="http://schemas.openxmlformats.org/drawingml/2006/main">
+            <a:off x="971550" y="5791200"/>
+            <a:ext cx="10248900" cy="381000"/>
           </a:xfrm>
           <a:prstGeom xmlns:a="http://schemas.openxmlformats.org/drawingml/2006/main" prst="rect">
             <a:avLst/>
@@ -3366,750 +4110,6 @@
           <a:p xmlns:a="http://schemas.openxmlformats.org/drawingml/2006/main">
             <a:pPr algn="ctr">
               <a:buNone/>
-              <a:defRPr sz="2400" b="1" i="0">
-                <a:solidFill>
-                  <a:srgbClr val="126B46"/>
-                </a:solidFill>
-              </a:defRPr>
-            </a:pPr>
-            <a:r>
-              <a:rPr sz="2400" b="1" i="0">
-                <a:solidFill>
-                  <a:srgbClr val="126B46"/>
-                </a:solidFill>
-              </a:rPr>
-              <a:t>→</a:t>
-            </a:r>
-          </a:p>
-        </p:txBody>
-      </p:sp>
-      <p:sp>
-        <p:nvSpPr>
-          <p:cNvPr id="9" name="">
-            <a:extLst xmlns:a="http://schemas.openxmlformats.org/drawingml/2006/main">
-              <a:ext uri="{FF2B5EF4-FFF2-40B4-BE49-F238E27FC236}">
-                <a16:creationId xmlns:a16="http://schemas.microsoft.com/office/drawing/2014/main" id="{2A1F5186-DE14-4D0C-A620-9DFA8814F16F}"/>
-              </a:ext>
-            </a:extLst>
-          </p:cNvPr>
-          <p:cNvSpPr>
-            <a:spLocks xmlns:a="http://schemas.openxmlformats.org/drawingml/2006/main" noGrp="1"/>
-          </p:cNvSpPr>
-          <p:nvPr/>
-        </p:nvSpPr>
-        <p:spPr>
-          <a:xfrm xmlns:a="http://schemas.openxmlformats.org/drawingml/2006/main">
-            <a:off x="3390900" y="2381250"/>
-            <a:ext cx="628650" cy="857250"/>
-          </a:xfrm>
-          <a:prstGeom xmlns:a="http://schemas.openxmlformats.org/drawingml/2006/main" prst="rect">
-            <a:avLst/>
-          </a:prstGeom>
-          <a:noFill xmlns:a="http://schemas.openxmlformats.org/drawingml/2006/main"/>
-          <a:ln xmlns:a="http://schemas.openxmlformats.org/drawingml/2006/main" w="0">
-            <a:noFill/>
-            <a:prstDash val="solid"/>
-          </a:ln>
-        </p:spPr>
-        <p:txBody>
-          <a:bodyPr xmlns:a="http://schemas.openxmlformats.org/drawingml/2006/main" anchor="t"/>
-          <a:lstStyle xmlns:a="http://schemas.openxmlformats.org/drawingml/2006/main"/>
-          <a:p xmlns:a="http://schemas.openxmlformats.org/drawingml/2006/main">
-            <a:pPr algn="l">
-              <a:buNone/>
-              <a:defRPr sz="5250" b="0" i="0">
-                <a:solidFill>
-                  <a:srgbClr val="AFD12F"/>
-                </a:solidFill>
-              </a:defRPr>
-            </a:pPr>
-            <a:r>
-              <a:rPr sz="5250" b="0" i="0">
-                <a:solidFill>
-                  <a:srgbClr val="AFD12F"/>
-                </a:solidFill>
-              </a:rPr>
-              <a:t>2</a:t>
-            </a:r>
-          </a:p>
-        </p:txBody>
-      </p:sp>
-      <p:sp>
-        <p:nvSpPr>
-          <p:cNvPr id="10" name="">
-            <a:extLst xmlns:a="http://schemas.openxmlformats.org/drawingml/2006/main">
-              <a:ext uri="{FF2B5EF4-FFF2-40B4-BE49-F238E27FC236}">
-                <a16:creationId xmlns:a16="http://schemas.microsoft.com/office/drawing/2014/main" id="{513F95F0-7B6E-4991-8A5F-1ED7228BBF1F}"/>
-              </a:ext>
-            </a:extLst>
-          </p:cNvPr>
-          <p:cNvSpPr>
-            <a:spLocks xmlns:a="http://schemas.openxmlformats.org/drawingml/2006/main" noGrp="1"/>
-          </p:cNvSpPr>
-          <p:nvPr/>
-        </p:nvSpPr>
-        <p:spPr>
-          <a:xfrm xmlns:a="http://schemas.openxmlformats.org/drawingml/2006/main">
-            <a:off x="3390900" y="3352800"/>
-            <a:ext cx="2171700" cy="28575"/>
-          </a:xfrm>
-          <a:prstGeom xmlns:a="http://schemas.openxmlformats.org/drawingml/2006/main" prst="rect">
-            <a:avLst/>
-          </a:prstGeom>
-          <a:solidFill xmlns:a="http://schemas.openxmlformats.org/drawingml/2006/main">
-            <a:srgbClr val="12241C"/>
-          </a:solidFill>
-          <a:ln xmlns:a="http://schemas.openxmlformats.org/drawingml/2006/main" w="0">
-            <a:solidFill>
-              <a:srgbClr val="12241C"/>
-            </a:solidFill>
-            <a:prstDash val="solid"/>
-          </a:ln>
-        </p:spPr>
-      </p:sp>
-      <p:sp>
-        <p:nvSpPr>
-          <p:cNvPr id="11" name="">
-            <a:extLst xmlns:a="http://schemas.openxmlformats.org/drawingml/2006/main">
-              <a:ext uri="{FF2B5EF4-FFF2-40B4-BE49-F238E27FC236}">
-                <a16:creationId xmlns:a16="http://schemas.microsoft.com/office/drawing/2014/main" id="{122137D4-5CC2-4DF0-86F7-314AAAC30B53}"/>
-              </a:ext>
-            </a:extLst>
-          </p:cNvPr>
-          <p:cNvSpPr>
-            <a:spLocks xmlns:a="http://schemas.openxmlformats.org/drawingml/2006/main" noGrp="1"/>
-          </p:cNvSpPr>
-          <p:nvPr/>
-        </p:nvSpPr>
-        <p:spPr>
-          <a:xfrm xmlns:a="http://schemas.openxmlformats.org/drawingml/2006/main">
-            <a:off x="3390900" y="3619500"/>
-            <a:ext cx="2095500" cy="381000"/>
-          </a:xfrm>
-          <a:prstGeom xmlns:a="http://schemas.openxmlformats.org/drawingml/2006/main" prst="rect">
-            <a:avLst/>
-          </a:prstGeom>
-          <a:noFill xmlns:a="http://schemas.openxmlformats.org/drawingml/2006/main"/>
-          <a:ln xmlns:a="http://schemas.openxmlformats.org/drawingml/2006/main" w="0">
-            <a:noFill/>
-            <a:prstDash val="solid"/>
-          </a:ln>
-        </p:spPr>
-        <p:txBody>
-          <a:bodyPr xmlns:a="http://schemas.openxmlformats.org/drawingml/2006/main" anchor="t"/>
-          <a:lstStyle xmlns:a="http://schemas.openxmlformats.org/drawingml/2006/main"/>
-          <a:p xmlns:a="http://schemas.openxmlformats.org/drawingml/2006/main">
-            <a:pPr algn="l">
-              <a:buNone/>
-              <a:defRPr sz="2025" b="1" i="0">
-                <a:solidFill>
-                  <a:srgbClr val="12241C"/>
-                </a:solidFill>
-              </a:defRPr>
-            </a:pPr>
-            <a:r>
-              <a:rPr sz="2025" b="1" i="0">
-                <a:solidFill>
-                  <a:srgbClr val="12241C"/>
-                </a:solidFill>
-              </a:rPr>
-              <a:t>Observe</a:t>
-            </a:r>
-          </a:p>
-        </p:txBody>
-      </p:sp>
-      <p:sp>
-        <p:nvSpPr>
-          <p:cNvPr id="12" name="">
-            <a:extLst xmlns:a="http://schemas.openxmlformats.org/drawingml/2006/main">
-              <a:ext uri="{FF2B5EF4-FFF2-40B4-BE49-F238E27FC236}">
-                <a16:creationId xmlns:a16="http://schemas.microsoft.com/office/drawing/2014/main" id="{A028D5A6-40C8-45DC-857C-E4D84A8F93B2}"/>
-              </a:ext>
-            </a:extLst>
-          </p:cNvPr>
-          <p:cNvSpPr>
-            <a:spLocks xmlns:a="http://schemas.openxmlformats.org/drawingml/2006/main" noGrp="1"/>
-          </p:cNvSpPr>
-          <p:nvPr/>
-        </p:nvSpPr>
-        <p:spPr>
-          <a:xfrm xmlns:a="http://schemas.openxmlformats.org/drawingml/2006/main">
-            <a:off x="3390900" y="4114800"/>
-            <a:ext cx="2171700" cy="1066800"/>
-          </a:xfrm>
-          <a:prstGeom xmlns:a="http://schemas.openxmlformats.org/drawingml/2006/main" prst="rect">
-            <a:avLst/>
-          </a:prstGeom>
-          <a:noFill xmlns:a="http://schemas.openxmlformats.org/drawingml/2006/main"/>
-          <a:ln xmlns:a="http://schemas.openxmlformats.org/drawingml/2006/main" w="0">
-            <a:noFill/>
-            <a:prstDash val="solid"/>
-          </a:ln>
-        </p:spPr>
-        <p:txBody>
-          <a:bodyPr xmlns:a="http://schemas.openxmlformats.org/drawingml/2006/main" anchor="t"/>
-          <a:lstStyle xmlns:a="http://schemas.openxmlformats.org/drawingml/2006/main"/>
-          <a:p xmlns:a="http://schemas.openxmlformats.org/drawingml/2006/main">
-            <a:pPr algn="l">
-              <a:buNone/>
-              <a:defRPr sz="1350" b="0" i="0">
-                <a:solidFill>
-                  <a:srgbClr val="556159"/>
-                </a:solidFill>
-              </a:defRPr>
-            </a:pPr>
-            <a:r>
-              <a:rPr sz="1350" b="0" i="0">
-                <a:solidFill>
-                  <a:srgbClr val="556159"/>
-                </a:solidFill>
-              </a:rPr>
-              <a:t>Typed browser checks inspect an authorized staging build.</a:t>
-            </a:r>
-          </a:p>
-        </p:txBody>
-      </p:sp>
-      <p:sp>
-        <p:nvSpPr>
-          <p:cNvPr id="13" name="">
-            <a:extLst xmlns:a="http://schemas.openxmlformats.org/drawingml/2006/main">
-              <a:ext uri="{FF2B5EF4-FFF2-40B4-BE49-F238E27FC236}">
-                <a16:creationId xmlns:a16="http://schemas.microsoft.com/office/drawing/2014/main" id="{AFFDCF95-5DEE-4FE8-905E-D1132BB52D0C}"/>
-              </a:ext>
-            </a:extLst>
-          </p:cNvPr>
-          <p:cNvSpPr>
-            <a:spLocks xmlns:a="http://schemas.openxmlformats.org/drawingml/2006/main" noGrp="1"/>
-          </p:cNvSpPr>
-          <p:nvPr/>
-        </p:nvSpPr>
-        <p:spPr>
-          <a:xfrm xmlns:a="http://schemas.openxmlformats.org/drawingml/2006/main">
-            <a:off x="5638800" y="2857500"/>
-            <a:ext cx="381000" cy="457200"/>
-          </a:xfrm>
-          <a:prstGeom xmlns:a="http://schemas.openxmlformats.org/drawingml/2006/main" prst="rect">
-            <a:avLst/>
-          </a:prstGeom>
-          <a:noFill xmlns:a="http://schemas.openxmlformats.org/drawingml/2006/main"/>
-          <a:ln xmlns:a="http://schemas.openxmlformats.org/drawingml/2006/main" w="0">
-            <a:noFill/>
-            <a:prstDash val="solid"/>
-          </a:ln>
-        </p:spPr>
-        <p:txBody>
-          <a:bodyPr xmlns:a="http://schemas.openxmlformats.org/drawingml/2006/main" anchor="t"/>
-          <a:lstStyle xmlns:a="http://schemas.openxmlformats.org/drawingml/2006/main"/>
-          <a:p xmlns:a="http://schemas.openxmlformats.org/drawingml/2006/main">
-            <a:pPr algn="ctr">
-              <a:buNone/>
-              <a:defRPr sz="2400" b="1" i="0">
-                <a:solidFill>
-                  <a:srgbClr val="126B46"/>
-                </a:solidFill>
-              </a:defRPr>
-            </a:pPr>
-            <a:r>
-              <a:rPr sz="2400" b="1" i="0">
-                <a:solidFill>
-                  <a:srgbClr val="126B46"/>
-                </a:solidFill>
-              </a:rPr>
-              <a:t>→</a:t>
-            </a:r>
-          </a:p>
-        </p:txBody>
-      </p:sp>
-      <p:sp>
-        <p:nvSpPr>
-          <p:cNvPr id="14" name="">
-            <a:extLst xmlns:a="http://schemas.openxmlformats.org/drawingml/2006/main">
-              <a:ext uri="{FF2B5EF4-FFF2-40B4-BE49-F238E27FC236}">
-                <a16:creationId xmlns:a16="http://schemas.microsoft.com/office/drawing/2014/main" id="{98052F4F-98AA-4C1D-A8E4-D9B5EC0057EF}"/>
-              </a:ext>
-            </a:extLst>
-          </p:cNvPr>
-          <p:cNvSpPr>
-            <a:spLocks xmlns:a="http://schemas.openxmlformats.org/drawingml/2006/main" noGrp="1"/>
-          </p:cNvSpPr>
-          <p:nvPr/>
-        </p:nvSpPr>
-        <p:spPr>
-          <a:xfrm xmlns:a="http://schemas.openxmlformats.org/drawingml/2006/main">
-            <a:off x="6096000" y="2381250"/>
-            <a:ext cx="628650" cy="857250"/>
-          </a:xfrm>
-          <a:prstGeom xmlns:a="http://schemas.openxmlformats.org/drawingml/2006/main" prst="rect">
-            <a:avLst/>
-          </a:prstGeom>
-          <a:noFill xmlns:a="http://schemas.openxmlformats.org/drawingml/2006/main"/>
-          <a:ln xmlns:a="http://schemas.openxmlformats.org/drawingml/2006/main" w="0">
-            <a:noFill/>
-            <a:prstDash val="solid"/>
-          </a:ln>
-        </p:spPr>
-        <p:txBody>
-          <a:bodyPr xmlns:a="http://schemas.openxmlformats.org/drawingml/2006/main" anchor="t"/>
-          <a:lstStyle xmlns:a="http://schemas.openxmlformats.org/drawingml/2006/main"/>
-          <a:p xmlns:a="http://schemas.openxmlformats.org/drawingml/2006/main">
-            <a:pPr algn="l">
-              <a:buNone/>
-              <a:defRPr sz="5250" b="0" i="0">
-                <a:solidFill>
-                  <a:srgbClr val="126B46"/>
-                </a:solidFill>
-              </a:defRPr>
-            </a:pPr>
-            <a:r>
-              <a:rPr sz="5250" b="0" i="0">
-                <a:solidFill>
-                  <a:srgbClr val="126B46"/>
-                </a:solidFill>
-              </a:rPr>
-              <a:t>3</a:t>
-            </a:r>
-          </a:p>
-        </p:txBody>
-      </p:sp>
-      <p:sp>
-        <p:nvSpPr>
-          <p:cNvPr id="15" name="">
-            <a:extLst xmlns:a="http://schemas.openxmlformats.org/drawingml/2006/main">
-              <a:ext uri="{FF2B5EF4-FFF2-40B4-BE49-F238E27FC236}">
-                <a16:creationId xmlns:a16="http://schemas.microsoft.com/office/drawing/2014/main" id="{DCBAF01D-4D3B-4556-8E45-A0C7938B81D5}"/>
-              </a:ext>
-            </a:extLst>
-          </p:cNvPr>
-          <p:cNvSpPr>
-            <a:spLocks xmlns:a="http://schemas.openxmlformats.org/drawingml/2006/main" noGrp="1"/>
-          </p:cNvSpPr>
-          <p:nvPr/>
-        </p:nvSpPr>
-        <p:spPr>
-          <a:xfrm xmlns:a="http://schemas.openxmlformats.org/drawingml/2006/main">
-            <a:off x="6096000" y="3352800"/>
-            <a:ext cx="2171700" cy="28575"/>
-          </a:xfrm>
-          <a:prstGeom xmlns:a="http://schemas.openxmlformats.org/drawingml/2006/main" prst="rect">
-            <a:avLst/>
-          </a:prstGeom>
-          <a:solidFill xmlns:a="http://schemas.openxmlformats.org/drawingml/2006/main">
-            <a:srgbClr val="126B46"/>
-          </a:solidFill>
-          <a:ln xmlns:a="http://schemas.openxmlformats.org/drawingml/2006/main" w="0">
-            <a:solidFill>
-              <a:srgbClr val="126B46"/>
-            </a:solidFill>
-            <a:prstDash val="solid"/>
-          </a:ln>
-        </p:spPr>
-      </p:sp>
-      <p:sp>
-        <p:nvSpPr>
-          <p:cNvPr id="16" name="">
-            <a:extLst xmlns:a="http://schemas.openxmlformats.org/drawingml/2006/main">
-              <a:ext uri="{FF2B5EF4-FFF2-40B4-BE49-F238E27FC236}">
-                <a16:creationId xmlns:a16="http://schemas.microsoft.com/office/drawing/2014/main" id="{C467E517-4EFA-4EBE-971E-A873FE666CCB}"/>
-              </a:ext>
-            </a:extLst>
-          </p:cNvPr>
-          <p:cNvSpPr>
-            <a:spLocks xmlns:a="http://schemas.openxmlformats.org/drawingml/2006/main" noGrp="1"/>
-          </p:cNvSpPr>
-          <p:nvPr/>
-        </p:nvSpPr>
-        <p:spPr>
-          <a:xfrm xmlns:a="http://schemas.openxmlformats.org/drawingml/2006/main">
-            <a:off x="6096000" y="3619500"/>
-            <a:ext cx="2095500" cy="381000"/>
-          </a:xfrm>
-          <a:prstGeom xmlns:a="http://schemas.openxmlformats.org/drawingml/2006/main" prst="rect">
-            <a:avLst/>
-          </a:prstGeom>
-          <a:noFill xmlns:a="http://schemas.openxmlformats.org/drawingml/2006/main"/>
-          <a:ln xmlns:a="http://schemas.openxmlformats.org/drawingml/2006/main" w="0">
-            <a:noFill/>
-            <a:prstDash val="solid"/>
-          </a:ln>
-        </p:spPr>
-        <p:txBody>
-          <a:bodyPr xmlns:a="http://schemas.openxmlformats.org/drawingml/2006/main" anchor="t"/>
-          <a:lstStyle xmlns:a="http://schemas.openxmlformats.org/drawingml/2006/main"/>
-          <a:p xmlns:a="http://schemas.openxmlformats.org/drawingml/2006/main">
-            <a:pPr algn="l">
-              <a:buNone/>
-              <a:defRPr sz="2025" b="1" i="0">
-                <a:solidFill>
-                  <a:srgbClr val="12241C"/>
-                </a:solidFill>
-              </a:defRPr>
-            </a:pPr>
-            <a:r>
-              <a:rPr sz="2025" b="1" i="0">
-                <a:solidFill>
-                  <a:srgbClr val="12241C"/>
-                </a:solidFill>
-              </a:rPr>
-              <a:t>Decide</a:t>
-            </a:r>
-          </a:p>
-        </p:txBody>
-      </p:sp>
-      <p:sp>
-        <p:nvSpPr>
-          <p:cNvPr id="17" name="">
-            <a:extLst xmlns:a="http://schemas.openxmlformats.org/drawingml/2006/main">
-              <a:ext uri="{FF2B5EF4-FFF2-40B4-BE49-F238E27FC236}">
-                <a16:creationId xmlns:a16="http://schemas.microsoft.com/office/drawing/2014/main" id="{39C04965-C345-4364-8DE5-EC23C2A41C6C}"/>
-              </a:ext>
-            </a:extLst>
-          </p:cNvPr>
-          <p:cNvSpPr>
-            <a:spLocks xmlns:a="http://schemas.openxmlformats.org/drawingml/2006/main" noGrp="1"/>
-          </p:cNvSpPr>
-          <p:nvPr/>
-        </p:nvSpPr>
-        <p:spPr>
-          <a:xfrm xmlns:a="http://schemas.openxmlformats.org/drawingml/2006/main">
-            <a:off x="6096000" y="4114800"/>
-            <a:ext cx="2171700" cy="1066800"/>
-          </a:xfrm>
-          <a:prstGeom xmlns:a="http://schemas.openxmlformats.org/drawingml/2006/main" prst="rect">
-            <a:avLst/>
-          </a:prstGeom>
-          <a:noFill xmlns:a="http://schemas.openxmlformats.org/drawingml/2006/main"/>
-          <a:ln xmlns:a="http://schemas.openxmlformats.org/drawingml/2006/main" w="0">
-            <a:noFill/>
-            <a:prstDash val="solid"/>
-          </a:ln>
-        </p:spPr>
-        <p:txBody>
-          <a:bodyPr xmlns:a="http://schemas.openxmlformats.org/drawingml/2006/main" anchor="t"/>
-          <a:lstStyle xmlns:a="http://schemas.openxmlformats.org/drawingml/2006/main"/>
-          <a:p xmlns:a="http://schemas.openxmlformats.org/drawingml/2006/main">
-            <a:pPr algn="l">
-              <a:buNone/>
-              <a:defRPr sz="1350" b="0" i="0">
-                <a:solidFill>
-                  <a:srgbClr val="556159"/>
-                </a:solidFill>
-              </a:defRPr>
-            </a:pPr>
-            <a:r>
-              <a:rPr sz="1350" b="0" i="0">
-                <a:solidFill>
-                  <a:srgbClr val="556159"/>
-                </a:solidFill>
-              </a:rPr>
-              <a:t>One named reviewer sees the promise, result, evidence, and deadline.</a:t>
-            </a:r>
-          </a:p>
-        </p:txBody>
-      </p:sp>
-      <p:sp>
-        <p:nvSpPr>
-          <p:cNvPr id="18" name="">
-            <a:extLst xmlns:a="http://schemas.openxmlformats.org/drawingml/2006/main">
-              <a:ext uri="{FF2B5EF4-FFF2-40B4-BE49-F238E27FC236}">
-                <a16:creationId xmlns:a16="http://schemas.microsoft.com/office/drawing/2014/main" id="{52EE9594-0759-4C30-B2D5-88747D30C22A}"/>
-              </a:ext>
-            </a:extLst>
-          </p:cNvPr>
-          <p:cNvSpPr>
-            <a:spLocks xmlns:a="http://schemas.openxmlformats.org/drawingml/2006/main" noGrp="1"/>
-          </p:cNvSpPr>
-          <p:nvPr/>
-        </p:nvSpPr>
-        <p:spPr>
-          <a:xfrm xmlns:a="http://schemas.openxmlformats.org/drawingml/2006/main">
-            <a:off x="8343900" y="2857500"/>
-            <a:ext cx="381000" cy="457200"/>
-          </a:xfrm>
-          <a:prstGeom xmlns:a="http://schemas.openxmlformats.org/drawingml/2006/main" prst="rect">
-            <a:avLst/>
-          </a:prstGeom>
-          <a:noFill xmlns:a="http://schemas.openxmlformats.org/drawingml/2006/main"/>
-          <a:ln xmlns:a="http://schemas.openxmlformats.org/drawingml/2006/main" w="0">
-            <a:noFill/>
-            <a:prstDash val="solid"/>
-          </a:ln>
-        </p:spPr>
-        <p:txBody>
-          <a:bodyPr xmlns:a="http://schemas.openxmlformats.org/drawingml/2006/main" anchor="t"/>
-          <a:lstStyle xmlns:a="http://schemas.openxmlformats.org/drawingml/2006/main"/>
-          <a:p xmlns:a="http://schemas.openxmlformats.org/drawingml/2006/main">
-            <a:pPr algn="ctr">
-              <a:buNone/>
-              <a:defRPr sz="2400" b="1" i="0">
-                <a:solidFill>
-                  <a:srgbClr val="126B46"/>
-                </a:solidFill>
-              </a:defRPr>
-            </a:pPr>
-            <a:r>
-              <a:rPr sz="2400" b="1" i="0">
-                <a:solidFill>
-                  <a:srgbClr val="126B46"/>
-                </a:solidFill>
-              </a:rPr>
-              <a:t>→</a:t>
-            </a:r>
-          </a:p>
-        </p:txBody>
-      </p:sp>
-      <p:sp>
-        <p:nvSpPr>
-          <p:cNvPr id="19" name="">
-            <a:extLst xmlns:a="http://schemas.openxmlformats.org/drawingml/2006/main">
-              <a:ext uri="{FF2B5EF4-FFF2-40B4-BE49-F238E27FC236}">
-                <a16:creationId xmlns:a16="http://schemas.microsoft.com/office/drawing/2014/main" id="{0157D690-D188-4A5C-B2F2-7141C6898C38}"/>
-              </a:ext>
-            </a:extLst>
-          </p:cNvPr>
-          <p:cNvSpPr>
-            <a:spLocks xmlns:a="http://schemas.openxmlformats.org/drawingml/2006/main" noGrp="1"/>
-          </p:cNvSpPr>
-          <p:nvPr/>
-        </p:nvSpPr>
-        <p:spPr>
-          <a:xfrm xmlns:a="http://schemas.openxmlformats.org/drawingml/2006/main">
-            <a:off x="8801100" y="2381250"/>
-            <a:ext cx="628650" cy="857250"/>
-          </a:xfrm>
-          <a:prstGeom xmlns:a="http://schemas.openxmlformats.org/drawingml/2006/main" prst="rect">
-            <a:avLst/>
-          </a:prstGeom>
-          <a:noFill xmlns:a="http://schemas.openxmlformats.org/drawingml/2006/main"/>
-          <a:ln xmlns:a="http://schemas.openxmlformats.org/drawingml/2006/main" w="0">
-            <a:noFill/>
-            <a:prstDash val="solid"/>
-          </a:ln>
-        </p:spPr>
-        <p:txBody>
-          <a:bodyPr xmlns:a="http://schemas.openxmlformats.org/drawingml/2006/main" anchor="t"/>
-          <a:lstStyle xmlns:a="http://schemas.openxmlformats.org/drawingml/2006/main"/>
-          <a:p xmlns:a="http://schemas.openxmlformats.org/drawingml/2006/main">
-            <a:pPr algn="l">
-              <a:buNone/>
-              <a:defRPr sz="5250" b="0" i="0">
-                <a:solidFill>
-                  <a:srgbClr val="AFD12F"/>
-                </a:solidFill>
-              </a:defRPr>
-            </a:pPr>
-            <a:r>
-              <a:rPr sz="5250" b="0" i="0">
-                <a:solidFill>
-                  <a:srgbClr val="AFD12F"/>
-                </a:solidFill>
-              </a:rPr>
-              <a:t>4</a:t>
-            </a:r>
-          </a:p>
-        </p:txBody>
-      </p:sp>
-      <p:sp>
-        <p:nvSpPr>
-          <p:cNvPr id="20" name="">
-            <a:extLst xmlns:a="http://schemas.openxmlformats.org/drawingml/2006/main">
-              <a:ext uri="{FF2B5EF4-FFF2-40B4-BE49-F238E27FC236}">
-                <a16:creationId xmlns:a16="http://schemas.microsoft.com/office/drawing/2014/main" id="{3B6D7763-A013-4F85-A5DB-2A242BCF820C}"/>
-              </a:ext>
-            </a:extLst>
-          </p:cNvPr>
-          <p:cNvSpPr>
-            <a:spLocks xmlns:a="http://schemas.openxmlformats.org/drawingml/2006/main" noGrp="1"/>
-          </p:cNvSpPr>
-          <p:nvPr/>
-        </p:nvSpPr>
-        <p:spPr>
-          <a:xfrm xmlns:a="http://schemas.openxmlformats.org/drawingml/2006/main">
-            <a:off x="8801100" y="3352800"/>
-            <a:ext cx="2171700" cy="28575"/>
-          </a:xfrm>
-          <a:prstGeom xmlns:a="http://schemas.openxmlformats.org/drawingml/2006/main" prst="rect">
-            <a:avLst/>
-          </a:prstGeom>
-          <a:solidFill xmlns:a="http://schemas.openxmlformats.org/drawingml/2006/main">
-            <a:srgbClr val="12241C"/>
-          </a:solidFill>
-          <a:ln xmlns:a="http://schemas.openxmlformats.org/drawingml/2006/main" w="0">
-            <a:solidFill>
-              <a:srgbClr val="12241C"/>
-            </a:solidFill>
-            <a:prstDash val="solid"/>
-          </a:ln>
-        </p:spPr>
-      </p:sp>
-      <p:sp>
-        <p:nvSpPr>
-          <p:cNvPr id="21" name="">
-            <a:extLst xmlns:a="http://schemas.openxmlformats.org/drawingml/2006/main">
-              <a:ext uri="{FF2B5EF4-FFF2-40B4-BE49-F238E27FC236}">
-                <a16:creationId xmlns:a16="http://schemas.microsoft.com/office/drawing/2014/main" id="{78F0E32D-497C-4195-A7B8-6C1DFABB3EAC}"/>
-              </a:ext>
-            </a:extLst>
-          </p:cNvPr>
-          <p:cNvSpPr>
-            <a:spLocks xmlns:a="http://schemas.openxmlformats.org/drawingml/2006/main" noGrp="1"/>
-          </p:cNvSpPr>
-          <p:nvPr/>
-        </p:nvSpPr>
-        <p:spPr>
-          <a:xfrm xmlns:a="http://schemas.openxmlformats.org/drawingml/2006/main">
-            <a:off x="8801100" y="3619500"/>
-            <a:ext cx="2095500" cy="381000"/>
-          </a:xfrm>
-          <a:prstGeom xmlns:a="http://schemas.openxmlformats.org/drawingml/2006/main" prst="rect">
-            <a:avLst/>
-          </a:prstGeom>
-          <a:noFill xmlns:a="http://schemas.openxmlformats.org/drawingml/2006/main"/>
-          <a:ln xmlns:a="http://schemas.openxmlformats.org/drawingml/2006/main" w="0">
-            <a:noFill/>
-            <a:prstDash val="solid"/>
-          </a:ln>
-        </p:spPr>
-        <p:txBody>
-          <a:bodyPr xmlns:a="http://schemas.openxmlformats.org/drawingml/2006/main" anchor="t"/>
-          <a:lstStyle xmlns:a="http://schemas.openxmlformats.org/drawingml/2006/main"/>
-          <a:p xmlns:a="http://schemas.openxmlformats.org/drawingml/2006/main">
-            <a:pPr algn="l">
-              <a:buNone/>
-              <a:defRPr sz="2025" b="1" i="0">
-                <a:solidFill>
-                  <a:srgbClr val="12241C"/>
-                </a:solidFill>
-              </a:defRPr>
-            </a:pPr>
-            <a:r>
-              <a:rPr sz="2025" b="1" i="0">
-                <a:solidFill>
-                  <a:srgbClr val="12241C"/>
-                </a:solidFill>
-              </a:rPr>
-              <a:t>Record</a:t>
-            </a:r>
-          </a:p>
-        </p:txBody>
-      </p:sp>
-      <p:sp>
-        <p:nvSpPr>
-          <p:cNvPr id="22" name="">
-            <a:extLst xmlns:a="http://schemas.openxmlformats.org/drawingml/2006/main">
-              <a:ext uri="{FF2B5EF4-FFF2-40B4-BE49-F238E27FC236}">
-                <a16:creationId xmlns:a16="http://schemas.microsoft.com/office/drawing/2014/main" id="{6FFC8E4E-B29E-41AB-9FED-83725DB4D9F2}"/>
-              </a:ext>
-            </a:extLst>
-          </p:cNvPr>
-          <p:cNvSpPr>
-            <a:spLocks xmlns:a="http://schemas.openxmlformats.org/drawingml/2006/main" noGrp="1"/>
-          </p:cNvSpPr>
-          <p:nvPr/>
-        </p:nvSpPr>
-        <p:spPr>
-          <a:xfrm xmlns:a="http://schemas.openxmlformats.org/drawingml/2006/main">
-            <a:off x="8801100" y="4114800"/>
-            <a:ext cx="2171700" cy="1066800"/>
-          </a:xfrm>
-          <a:prstGeom xmlns:a="http://schemas.openxmlformats.org/drawingml/2006/main" prst="rect">
-            <a:avLst/>
-          </a:prstGeom>
-          <a:noFill xmlns:a="http://schemas.openxmlformats.org/drawingml/2006/main"/>
-          <a:ln xmlns:a="http://schemas.openxmlformats.org/drawingml/2006/main" w="0">
-            <a:noFill/>
-            <a:prstDash val="solid"/>
-          </a:ln>
-        </p:spPr>
-        <p:txBody>
-          <a:bodyPr xmlns:a="http://schemas.openxmlformats.org/drawingml/2006/main" anchor="t"/>
-          <a:lstStyle xmlns:a="http://schemas.openxmlformats.org/drawingml/2006/main"/>
-          <a:p xmlns:a="http://schemas.openxmlformats.org/drawingml/2006/main">
-            <a:pPr algn="l">
-              <a:buNone/>
-              <a:defRPr sz="1350" b="0" i="0">
-                <a:solidFill>
-                  <a:srgbClr val="556159"/>
-                </a:solidFill>
-              </a:defRPr>
-            </a:pPr>
-            <a:r>
-              <a:rPr sz="1350" b="0" i="0">
-                <a:solidFill>
-                  <a:srgbClr val="556159"/>
-                </a:solidFill>
-              </a:rPr>
-              <a:t>The decision and invoice-ready context stay attached.</a:t>
-            </a:r>
-          </a:p>
-        </p:txBody>
-      </p:sp>
-      <p:sp>
-        <p:nvSpPr>
-          <p:cNvPr id="23" name="">
-            <a:extLst xmlns:a="http://schemas.openxmlformats.org/drawingml/2006/main">
-              <a:ext uri="{FF2B5EF4-FFF2-40B4-BE49-F238E27FC236}">
-                <a16:creationId xmlns:a16="http://schemas.microsoft.com/office/drawing/2014/main" id="{CF40982D-6FF5-4C5D-B701-2CFD04F0C00E}"/>
-              </a:ext>
-            </a:extLst>
-          </p:cNvPr>
-          <p:cNvSpPr>
-            <a:spLocks xmlns:a="http://schemas.openxmlformats.org/drawingml/2006/main" noGrp="1"/>
-          </p:cNvSpPr>
-          <p:nvPr/>
-        </p:nvSpPr>
-        <p:spPr>
-          <a:xfrm xmlns:a="http://schemas.openxmlformats.org/drawingml/2006/main">
-            <a:off x="685800" y="5686425"/>
-            <a:ext cx="10820400" cy="581025"/>
-          </a:xfrm>
-          <a:prstGeom xmlns:a="http://schemas.openxmlformats.org/drawingml/2006/main" prst="rect">
-            <a:avLst/>
-          </a:prstGeom>
-          <a:solidFill xmlns:a="http://schemas.openxmlformats.org/drawingml/2006/main">
-            <a:srgbClr val="12241C"/>
-          </a:solidFill>
-          <a:ln xmlns:a="http://schemas.openxmlformats.org/drawingml/2006/main" w="0">
-            <a:solidFill>
-              <a:srgbClr val="12241C"/>
-            </a:solidFill>
-            <a:prstDash val="solid"/>
-          </a:ln>
-        </p:spPr>
-      </p:sp>
-      <p:sp>
-        <p:nvSpPr>
-          <p:cNvPr id="24" name="">
-            <a:extLst xmlns:a="http://schemas.openxmlformats.org/drawingml/2006/main">
-              <a:ext uri="{FF2B5EF4-FFF2-40B4-BE49-F238E27FC236}">
-                <a16:creationId xmlns:a16="http://schemas.microsoft.com/office/drawing/2014/main" id="{CB057C7D-F805-4BE3-BD1A-10BDD9F5CF0C}"/>
-              </a:ext>
-            </a:extLst>
-          </p:cNvPr>
-          <p:cNvSpPr>
-            <a:spLocks xmlns:a="http://schemas.openxmlformats.org/drawingml/2006/main" noGrp="1"/>
-          </p:cNvSpPr>
-          <p:nvPr/>
-        </p:nvSpPr>
-        <p:spPr>
-          <a:xfrm xmlns:a="http://schemas.openxmlformats.org/drawingml/2006/main">
-            <a:off x="971550" y="5857875"/>
-            <a:ext cx="10248900" cy="304800"/>
-          </a:xfrm>
-          <a:prstGeom xmlns:a="http://schemas.openxmlformats.org/drawingml/2006/main" prst="rect">
-            <a:avLst/>
-          </a:prstGeom>
-          <a:noFill xmlns:a="http://schemas.openxmlformats.org/drawingml/2006/main"/>
-          <a:ln xmlns:a="http://schemas.openxmlformats.org/drawingml/2006/main" w="0">
-            <a:noFill/>
-            <a:prstDash val="solid"/>
-          </a:ln>
-        </p:spPr>
-        <p:txBody>
-          <a:bodyPr xmlns:a="http://schemas.openxmlformats.org/drawingml/2006/main" anchor="t"/>
-          <a:lstStyle xmlns:a="http://schemas.openxmlformats.org/drawingml/2006/main"/>
-          <a:p xmlns:a="http://schemas.openxmlformats.org/drawingml/2006/main">
-            <a:pPr algn="ctr">
-              <a:buNone/>
               <a:defRPr sz="1650" b="1" i="0">
                 <a:solidFill>
                   <a:srgbClr val="FFFEFA"/>
@@ -4122,7 +4122,7 @@
                   <a:srgbClr val="FFFEFA"/>
                 </a:solidFill>
               </a:rPr>
-              <a:t>AI drafts. The agency confirms. The browser observes. The client decides.</a:t>
+              <a:t>Your team confirms the criteria, the browser checks the work, and your client makes the call.</a:t>
             </a:r>
           </a:p>
         </p:txBody>
@@ -4275,7 +4275,7 @@
         <p:spPr>
           <a:xfrm xmlns:a="http://schemas.openxmlformats.org/drawingml/2006/main">
             <a:off x="685800" y="1000125"/>
-            <a:ext cx="7620000" cy="704850"/>
+            <a:ext cx="7620000" cy="1190625"/>
           </a:xfrm>
           <a:prstGeom xmlns:a="http://schemas.openxmlformats.org/drawingml/2006/main" prst="rect">
             <a:avLst/>
@@ -4355,7 +4355,7 @@
                   <a:srgbClr val="556159"/>
                 </a:solidFill>
               </a:rPr>
-              <a:t>The synthetic release candidate looks successful, while the underlying request fails. Greenlit keeps the observed failure attached to the frozen promise.</a:t>
+              <a:t>The test site says the form worked even though the request returned 500. Greenlit records that failure alongside the exact criterion.</a:t>
             </a:r>
           </a:p>
         </p:txBody>
@@ -4439,7 +4439,7 @@
                   <a:srgbClr val="B63F3A"/>
                 </a:solidFill>
               </a:rPr>
-              <a:t>AC-04 · NEEDS WORK</a:t>
+              <a:t>AC-04 · FAILED CHECK</a:t>
             </a:r>
           </a:p>
         </p:txBody>
@@ -4490,7 +4490,7 @@
                   <a:srgbClr val="12241C"/>
                 </a:solidFill>
               </a:rPr>
-              <a:t>Visible confirmation contradicted the HTTP 500 response.</a:t>
+              <a:t>The page showed success, but the server returned HTTP 500.</a:t>
             </a:r>
           </a:p>
         </p:txBody>
@@ -4504,7 +4504,7 @@
           <p:nvPr/>
         </p:nvPicPr>
         <p:blipFill>
-          <a:blip xmlns:r="http://schemas.openxmlformats.org/officeDocument/2006/relationships" xmlns:a="http://schemas.openxmlformats.org/drawingml/2006/main" r:embed="R436072ed5be94d1d"/>
+          <a:blip xmlns:r="http://schemas.openxmlformats.org/officeDocument/2006/relationships" xmlns:a="http://schemas.openxmlformats.org/drawingml/2006/main" r:embed="Rf17cf51aa5244972"/>
           <a:srcRect xmlns:a="http://schemas.openxmlformats.org/drawingml/2006/main" l="0" t="1064" r="0" b="1064"/>
           <a:stretch xmlns:a="http://schemas.openxmlformats.org/drawingml/2006/main">
             <a:fillRect l="0" t="0" r="0" b="0"/>
@@ -4512,8 +4512,8 @@
         </p:blipFill>
         <p:spPr>
           <a:xfrm xmlns:a="http://schemas.openxmlformats.org/drawingml/2006/main" flipH="0" flipV="0">
-            <a:off x="5191125" y="2238375"/>
-            <a:ext cx="6315075" cy="3476625"/>
+            <a:off x="5191125" y="2333625"/>
+            <a:ext cx="6315075" cy="3381375"/>
           </a:xfrm>
           <a:prstGeom xmlns:a="http://schemas.openxmlformats.org/drawingml/2006/main" prst="roundRect">
             <a:avLst/>
@@ -4566,7 +4566,7 @@
                   <a:srgbClr val="556159"/>
                 </a:solidFill>
               </a:rPr>
-              <a:t>Synthetic fixture · presentation evidence, not a retained runner artifact</a:t>
+              <a:t>Synthetic walkthrough evidence; no retained transaction was created.</a:t>
             </a:r>
           </a:p>
         </p:txBody>
@@ -4719,7 +4719,7 @@
         <p:spPr>
           <a:xfrm xmlns:a="http://schemas.openxmlformats.org/drawingml/2006/main">
             <a:off x="685800" y="1000125"/>
-            <a:ext cx="9334500" cy="723900"/>
+            <a:ext cx="9334500" cy="1143000"/>
           </a:xfrm>
           <a:prstGeom xmlns:a="http://schemas.openxmlformats.org/drawingml/2006/main" prst="rect">
             <a:avLst/>
@@ -4748,7 +4748,7 @@
                   <a:srgbClr val="12241C"/>
                 </a:solidFill>
               </a:rPr>
-              <a:t>The client sees the promise—not a test dashboard.</a:t>
+              <a:t>The client sees the promise, not a test dashboard.</a:t>
             </a:r>
           </a:p>
         </p:txBody>
@@ -4762,7 +4762,7 @@
           <p:nvPr/>
         </p:nvPicPr>
         <p:blipFill>
-          <a:blip xmlns:r="http://schemas.openxmlformats.org/officeDocument/2006/relationships" xmlns:a="http://schemas.openxmlformats.org/drawingml/2006/main" r:embed="Rb7707edffef3457d"/>
+          <a:blip xmlns:r="http://schemas.openxmlformats.org/officeDocument/2006/relationships" xmlns:a="http://schemas.openxmlformats.org/drawingml/2006/main" r:embed="Rd1425d87406c45ef"/>
           <a:srcRect xmlns:a="http://schemas.openxmlformats.org/drawingml/2006/main" l="112" t="0" r="112" b="0"/>
           <a:stretch xmlns:a="http://schemas.openxmlformats.org/drawingml/2006/main">
             <a:fillRect l="0" t="0" r="0" b="0"/>
@@ -4770,7 +4770,7 @@
         </p:blipFill>
         <p:spPr>
           <a:xfrm xmlns:a="http://schemas.openxmlformats.org/drawingml/2006/main" flipH="0" flipV="0">
-            <a:off x="685800" y="2095500"/>
+            <a:off x="685800" y="2333625"/>
             <a:ext cx="7096125" cy="4000500"/>
           </a:xfrm>
           <a:prstGeom xmlns:a="http://schemas.openxmlformats.org/drawingml/2006/main" prst="roundRect">
@@ -4794,8 +4794,8 @@
         </p:nvSpPr>
         <p:spPr>
           <a:xfrm xmlns:a="http://schemas.openxmlformats.org/drawingml/2006/main">
-            <a:off x="8334375" y="2381250"/>
-            <a:ext cx="2857500" cy="342900"/>
+            <a:off x="8334375" y="2571750"/>
+            <a:ext cx="2857500" cy="609600"/>
           </a:xfrm>
           <a:prstGeom xmlns:a="http://schemas.openxmlformats.org/drawingml/2006/main" prst="rect">
             <a:avLst/>
@@ -4824,7 +4824,7 @@
                   <a:srgbClr val="12241C"/>
                 </a:solidFill>
               </a:rPr>
-              <a:t>Exact source language</a:t>
+              <a:t>The original SOW clause</a:t>
             </a:r>
           </a:p>
         </p:txBody>
@@ -4845,8 +4845,8 @@
         </p:nvSpPr>
         <p:spPr>
           <a:xfrm xmlns:a="http://schemas.openxmlformats.org/drawingml/2006/main">
-            <a:off x="8334375" y="3190875"/>
-            <a:ext cx="2857500" cy="590550"/>
+            <a:off x="8334375" y="3381375"/>
+            <a:ext cx="2857500" cy="609600"/>
           </a:xfrm>
           <a:prstGeom xmlns:a="http://schemas.openxmlformats.org/drawingml/2006/main" prst="rect">
             <a:avLst/>
@@ -4875,7 +4875,7 @@
                   <a:srgbClr val="12241C"/>
                 </a:solidFill>
               </a:rPr>
-              <a:t>Expected and observed result</a:t>
+              <a:t>Expected result and actual result</a:t>
             </a:r>
           </a:p>
         </p:txBody>
@@ -4896,8 +4896,8 @@
         </p:nvSpPr>
         <p:spPr>
           <a:xfrm xmlns:a="http://schemas.openxmlformats.org/drawingml/2006/main">
-            <a:off x="8334375" y="4219575"/>
-            <a:ext cx="2857500" cy="342900"/>
+            <a:off x="8334375" y="4410075"/>
+            <a:ext cx="2857500" cy="609600"/>
           </a:xfrm>
           <a:prstGeom xmlns:a="http://schemas.openxmlformats.org/drawingml/2006/main" prst="rect">
             <a:avLst/>
@@ -4926,7 +4926,7 @@
                   <a:srgbClr val="12241C"/>
                 </a:solidFill>
               </a:rPr>
-              <a:t>Evidence and deadline</a:t>
+              <a:t>Evidence and the deadline</a:t>
             </a:r>
           </a:p>
         </p:txBody>
@@ -4947,8 +4947,8 @@
         </p:nvSpPr>
         <p:spPr>
           <a:xfrm xmlns:a="http://schemas.openxmlformats.org/drawingml/2006/main">
-            <a:off x="8334375" y="5029200"/>
-            <a:ext cx="2857500" cy="590550"/>
+            <a:off x="8334375" y="5219700"/>
+            <a:ext cx="2857500" cy="609600"/>
           </a:xfrm>
           <a:prstGeom xmlns:a="http://schemas.openxmlformats.org/drawingml/2006/main" prst="rect">
             <a:avLst/>
@@ -4967,14 +4967,14 @@
               <a:buNone/>
               <a:defRPr sz="1875" b="1" i="0">
                 <a:solidFill>
-                  <a:srgbClr val="126B46"/>
+                  <a:srgbClr val="12241C"/>
                 </a:solidFill>
               </a:defRPr>
             </a:pPr>
             <a:r>
               <a:rPr sz="1875" b="1" i="0">
                 <a:solidFill>
-                  <a:srgbClr val="126B46"/>
+                  <a:srgbClr val="12241C"/>
                 </a:solidFill>
               </a:rPr>
               <a:t>Approve or request changes</a:t>
@@ -5130,7 +5130,7 @@
         <p:spPr>
           <a:xfrm xmlns:a="http://schemas.openxmlformats.org/drawingml/2006/main">
             <a:off x="685800" y="1000125"/>
-            <a:ext cx="8858250" cy="714375"/>
+            <a:ext cx="8858250" cy="1190625"/>
           </a:xfrm>
           <a:prstGeom xmlns:a="http://schemas.openxmlformats.org/drawingml/2006/main" prst="rect">
             <a:avLst/>
@@ -5180,7 +5180,7 @@
         </p:nvSpPr>
         <p:spPr>
           <a:xfrm xmlns:a="http://schemas.openxmlformats.org/drawingml/2006/main">
-            <a:off x="685800" y="2000250"/>
+            <a:off x="685800" y="2333625"/>
             <a:ext cx="3762375" cy="1238250"/>
           </a:xfrm>
           <a:prstGeom xmlns:a="http://schemas.openxmlformats.org/drawingml/2006/main" prst="rect">
@@ -5210,7 +5210,7 @@
                   <a:srgbClr val="556159"/>
                 </a:solidFill>
               </a:rPr>
-              <a:t>One printable sample connects the milestone value, revision 1, observed build, local-only decision, and approval format.</a:t>
+              <a:t>The sample receipt keeps the milestone value, revision, observed build, and local-only decision in one place.</a:t>
             </a:r>
           </a:p>
         </p:txBody>
@@ -5232,7 +5232,7 @@
         <p:spPr>
           <a:xfrm xmlns:a="http://schemas.openxmlformats.org/drawingml/2006/main">
             <a:off x="685800" y="3838575"/>
-            <a:ext cx="1809750" cy="304800"/>
+            <a:ext cx="1809750" cy="342900"/>
           </a:xfrm>
           <a:prstGeom xmlns:a="http://schemas.openxmlformats.org/drawingml/2006/main" prst="rect">
             <a:avLst/>
@@ -5312,7 +5312,7 @@
                   <a:srgbClr val="12241C"/>
                 </a:solidFill>
               </a:rPr>
-              <a:t>A printable sample of the approval and billing handoff.</a:t>
+              <a:t>A printable summary of the approval and invoice handoff.</a:t>
             </a:r>
           </a:p>
         </p:txBody>
@@ -5334,7 +5334,7 @@
         <p:spPr>
           <a:xfrm xmlns:a="http://schemas.openxmlformats.org/drawingml/2006/main">
             <a:off x="685800" y="5143500"/>
-            <a:ext cx="1809750" cy="304800"/>
+            <a:ext cx="1809750" cy="342900"/>
           </a:xfrm>
           <a:prstGeom xmlns:a="http://schemas.openxmlformats.org/drawingml/2006/main" prst="rect">
             <a:avLst/>
@@ -5414,7 +5414,7 @@
                   <a:srgbClr val="12241C"/>
                 </a:solidFill>
               </a:rPr>
-              <a:t>A signature product, certification, ledger, or payment guarantee.</a:t>
+              <a:t>A signature, certification, payment record, or guarantee.</a:t>
             </a:r>
           </a:p>
         </p:txBody>
@@ -5428,7 +5428,7 @@
           <p:nvPr/>
         </p:nvPicPr>
         <p:blipFill>
-          <a:blip xmlns:r="http://schemas.openxmlformats.org/officeDocument/2006/relationships" xmlns:a="http://schemas.openxmlformats.org/drawingml/2006/main" r:embed="R223091b29d90427d"/>
+          <a:blip xmlns:r="http://schemas.openxmlformats.org/officeDocument/2006/relationships" xmlns:a="http://schemas.openxmlformats.org/drawingml/2006/main" r:embed="R96ef5566dc1c44ec"/>
           <a:srcRect xmlns:a="http://schemas.openxmlformats.org/drawingml/2006/main" l="9428" t="0" r="9428" b="0"/>
           <a:stretch xmlns:a="http://schemas.openxmlformats.org/drawingml/2006/main">
             <a:fillRect l="0" t="0" r="0" b="0"/>
@@ -5436,7 +5436,7 @@
         </p:blipFill>
         <p:spPr>
           <a:xfrm xmlns:a="http://schemas.openxmlformats.org/drawingml/2006/main" flipH="0" flipV="0">
-            <a:off x="5048250" y="1666875"/>
+            <a:off x="5048250" y="1809750"/>
             <a:ext cx="6457950" cy="4476750"/>
           </a:xfrm>
           <a:prstGeom xmlns:a="http://schemas.openxmlformats.org/drawingml/2006/main" prst="roundRect">
@@ -5592,7 +5592,7 @@
         <p:spPr>
           <a:xfrm xmlns:a="http://schemas.openxmlformats.org/drawingml/2006/main">
             <a:off x="685800" y="1000125"/>
-            <a:ext cx="8096250" cy="733425"/>
+            <a:ext cx="8096250" cy="1190625"/>
           </a:xfrm>
           <a:prstGeom xmlns:a="http://schemas.openxmlformats.org/drawingml/2006/main" prst="rect">
             <a:avLst/>
@@ -5621,7 +5621,7 @@
                   <a:srgbClr val="FFFEFA"/>
                 </a:solidFill>
               </a:rPr>
-              <a:t>AI drafts. Humans decide.</a:t>
+              <a:t>Gemini drafts the criteria, but people make every decision.</a:t>
             </a:r>
           </a:p>
         </p:txBody>
@@ -5669,7 +5669,7 @@
             <a:r>
               <a:rPr sz="1200" b="1" i="0">
                 <a:solidFill>
-                  <a:srgbClr val="D6FF61"/>
+                  <a:srgbClr val="B9D0C0"/>
                 </a:solidFill>
               </a:rPr>
               <a:t>ARCHITECTURE</a:t>
@@ -5741,7 +5741,7 @@
                   <a:srgbClr val="FFFEFA"/>
                 </a:solidFill>
               </a:rPr>
-              <a:t>Gemini + Zod extraction</a:t>
+              <a:t>Gemini with Zod validation</a:t>
             </a:r>
           </a:p>
           <a:p xmlns:a="http://schemas.openxmlformats.org/drawingml/2006/main">
@@ -5759,7 +5759,7 @@
                   <a:srgbClr val="FFFEFA"/>
                 </a:solidFill>
               </a:rPr>
-              <a:t>Cloudflare Queue + browser worker</a:t>
+              <a:t>Cloudflare Queue and browser worker</a:t>
             </a:r>
           </a:p>
           <a:p xmlns:a="http://schemas.openxmlformats.org/drawingml/2006/main">
@@ -5777,7 +5777,7 @@
                   <a:srgbClr val="FFFEFA"/>
                 </a:solidFill>
               </a:rPr>
-              <a:t>Supabase storage + RLS</a:t>
+              <a:t>Supabase with row-level security</a:t>
             </a:r>
           </a:p>
         </p:txBody>
@@ -5858,7 +5858,7 @@
             <a:r>
               <a:rPr sz="1200" b="1" i="0">
                 <a:solidFill>
-                  <a:srgbClr val="D6FF61"/>
+                  <a:srgbClr val="B9D0C0"/>
                 </a:solidFill>
               </a:rPr>
               <a:t>TRUST BOUNDARIES</a:t>
@@ -5912,7 +5912,7 @@
                   <a:srgbClr val="FFFEFA"/>
                 </a:solidFill>
               </a:rPr>
-              <a:t>Human-confirmed criteria</a:t>
+              <a:t>Criteria confirmed by a person</a:t>
             </a:r>
           </a:p>
           <a:p xmlns:a="http://schemas.openxmlformats.org/drawingml/2006/main">
@@ -5948,7 +5948,7 @@
                   <a:srgbClr val="FFFEFA"/>
                 </a:solidFill>
               </a:rPr>
-              <a:t>HMAC-signed jobs and callbacks</a:t>
+              <a:t>Signed jobs and callbacks</a:t>
             </a:r>
           </a:p>
           <a:p xmlns:a="http://schemas.openxmlformats.org/drawingml/2006/main">
@@ -5966,7 +5966,7 @@
                   <a:srgbClr val="FFFEFA"/>
                 </a:solidFill>
               </a:rPr>
-              <a:t>Private evidence with expiry</a:t>
+              <a:t>Private evidence that expires</a:t>
             </a:r>
           </a:p>
         </p:txBody>
@@ -5994,11 +5994,11 @@
             <a:avLst/>
           </a:prstGeom>
           <a:solidFill xmlns:a="http://schemas.openxmlformats.org/drawingml/2006/main">
-            <a:srgbClr val="D6FF61"/>
+            <a:srgbClr val="DCE8DF"/>
           </a:solidFill>
           <a:ln xmlns:a="http://schemas.openxmlformats.org/drawingml/2006/main" w="0">
             <a:solidFill>
-              <a:srgbClr val="D6FF61"/>
+              <a:srgbClr val="DCE8DF"/>
             </a:solidFill>
             <a:prstDash val="solid"/>
           </a:ln>
@@ -6050,7 +6050,7 @@
                   <a:srgbClr val="12241C"/>
                 </a:solidFill>
               </a:rPr>
-              <a:t>Stateless web tier · queued runners · frozen contracts keep the path scalable and repeatable</a:t>
+              <a:t>A stateless web app, queued runners, and frozen criteria keep every run repeatable.</a:t>
             </a:r>
           </a:p>
         </p:txBody>
@@ -6071,7 +6071,7 @@
     <p:bg>
       <p:bgPr>
         <a:solidFill xmlns:a="http://schemas.openxmlformats.org/drawingml/2006/main">
-          <a:srgbClr val="D6FF61"/>
+          <a:srgbClr val="DCE8DF"/>
         </a:solidFill>
       </p:bgPr>
     </p:bg>
@@ -6101,7 +6101,7 @@
         <p:spPr>
           <a:xfrm xmlns:a="http://schemas.openxmlformats.org/drawingml/2006/main">
             <a:off x="685800" y="876300"/>
-            <a:ext cx="9525000" cy="1219200"/>
+            <a:ext cx="9525000" cy="1333500"/>
           </a:xfrm>
           <a:prstGeom xmlns:a="http://schemas.openxmlformats.org/drawingml/2006/main" prst="rect">
             <a:avLst/>
@@ -6265,7 +6265,7 @@
                   <a:srgbClr val="12241C"/>
                 </a:solidFill>
               </a:rPr>
-              <a:t>Built during Blueprint 2026; a complete agency-to-client workflow.</a:t>
+              <a:t>Built from scratch during Blueprint 2026 as a full agency-to-client flow.</a:t>
             </a:r>
           </a:p>
         </p:txBody>
@@ -6367,7 +6367,7 @@
                   <a:srgbClr val="12241C"/>
                 </a:solidFill>
               </a:rPr>
-              <a:t>Typecheck, lint, tests, build, migrations, and browser flow passed.</a:t>
+              <a:t>Typecheck, lint, tests, build, migrations, and browser flows all passed.</a:t>
             </a:r>
           </a:p>
         </p:txBody>
@@ -6469,7 +6469,7 @@
                   <a:srgbClr val="12241C"/>
                 </a:solidFill>
               </a:rPr>
-              <a:t>Live product, source code, architecture, and demo flow.</a:t>
+              <a:t>Try the live walkthrough, then review the source and architecture.</a:t>
             </a:r>
           </a:p>
         </p:txBody>
@@ -6604,7 +6604,7 @@
                   <a:srgbClr val="12241C"/>
                 </a:solidFill>
               </a:rPr>
-              <a:t>GitHub repository:</a:t>
+              <a:t>github.com/</a:t>
             </a:r>
           </a:p>
           <a:p xmlns:a="http://schemas.openxmlformats.org/drawingml/2006/main">

</xml_diff>